<commit_message>
feat: add differentiation slide (Gemini vs NuanNuan) as slide 5
Insert comparison slide between Live Demo and Partnership sections
to preempt the most common objection: 'why not just use Gemini?'

Now 7 slides total. Time per slide ~43 seconds.
</commit_message>
<xml_diff>
--- a/pitch/暖暖-通路招商-5min.pptx
+++ b/pitch/暖暖-通路招商-5min.pptx
@@ -11,9 +11,10 @@
     <p:sldId id="259" r:id="rId5"/>
     <p:sldId id="260" r:id="rId6"/>
     <p:sldId id="261" r:id="rId7"/>
+    <p:sldId id="262" r:id="rId8"/>
   </p:sldIdLst>
   <p:notesMasterIdLst>
-    <p:notesMasterId r:id="rId8"/>
+    <p:notesMasterId r:id="rId9"/>
   </p:notesMasterIdLst>
   <p:sldSz cx="9144000" cy="5143500"/>
   <p:notesSz cx="5143500" cy="9144000"/>
@@ -989,6 +990,94 @@
 </p:notes>
 </file>
 
+<file path=ppt/notesSlides/notesSlide7.xml><?xml version="1.0" encoding="utf-8"?>
+<p:notes xmlns:a="http://schemas.openxmlformats.org/drawingml/2006/main" xmlns:r="http://schemas.openxmlformats.org/officeDocument/2006/relationships" xmlns:p="http://schemas.openxmlformats.org/presentationml/2006/main">
+  <p:cSld>
+    <p:spTree>
+      <p:nvGrpSpPr>
+        <p:cNvPr id="1" name=""/>
+        <p:cNvGrpSpPr/>
+        <p:nvPr/>
+      </p:nvGrpSpPr>
+      <p:grpSpPr>
+        <a:xfrm>
+          <a:off x="0" y="0"/>
+          <a:ext cx="0" cy="0"/>
+          <a:chOff x="0" y="0"/>
+          <a:chExt cx="0" cy="0"/>
+        </a:xfrm>
+      </p:grpSpPr>
+      <p:sp>
+        <p:nvSpPr>
+          <p:cNvPr id="2" name="Slide Image Placeholder 1"/>
+          <p:cNvSpPr>
+            <a:spLocks noGrp="1" noRot="1" noChangeAspect="1"/>
+          </p:cNvSpPr>
+          <p:nvPr>
+            <p:ph type="sldImg"/>
+          </p:nvPr>
+        </p:nvSpPr>
+        <p:spPr/>
+      </p:sp>
+      <p:sp>
+        <p:nvSpPr>
+          <p:cNvPr id="3" name="Notes Placeholder 2"/>
+          <p:cNvSpPr>
+            <a:spLocks noGrp="1"/>
+          </p:cNvSpPr>
+          <p:nvPr>
+            <p:ph type="body" idx="1"/>
+          </p:nvPr>
+        </p:nvSpPr>
+        <p:spPr/>
+        <p:txBody>
+          <a:bodyPr/>
+          <a:lstStyle/>
+          <a:p>
+            <a:r>
+              <a:rPr lang="en-US" dirty="0"/>
+              <a:t/>
+            </a:r>
+            <a:endParaRPr lang="en-US" dirty="0"/>
+          </a:p>
+        </p:txBody>
+      </p:sp>
+      <p:sp>
+        <p:nvSpPr>
+          <p:cNvPr id="4" name="Slide Number Placeholder 3"/>
+          <p:cNvSpPr>
+            <a:spLocks noGrp="1"/>
+          </p:cNvSpPr>
+          <p:nvPr>
+            <p:ph type="sldNum" sz="quarter" idx="10"/>
+          </p:nvPr>
+        </p:nvSpPr>
+        <p:spPr/>
+        <p:txBody>
+          <a:bodyPr/>
+          <a:lstStyle/>
+          <a:p>
+            <a:fld id="{F7021451-1387-4CA6-816F-3879F97B5CBC}" type="slidenum">
+              <a:rPr lang="en-US"/>
+              <a:t>7</a:t>
+            </a:fld>
+            <a:endParaRPr lang="en-US"/>
+          </a:p>
+        </p:txBody>
+      </p:sp>
+    </p:spTree>
+    <p:extLst>
+      <p:ext uri="{BB962C8B-B14F-4D97-AF65-F5344CB8AC3E}">
+        <p14:creationId xmlns:p14="http://schemas.microsoft.com/office/powerpoint/2010/main" val="1024086991"/>
+      </p:ext>
+    </p:extLst>
+  </p:cSld>
+  <p:clrMapOvr>
+    <a:masterClrMapping/>
+  </p:clrMapOvr>
+</p:notes>
+</file>
+
 <file path=ppt/slideLayouts/slideLayout1.xml><?xml version="1.0" encoding="utf-8"?>
 <p:sldLayout xmlns:a="http://schemas.openxmlformats.org/drawingml/2006/main" xmlns:r="http://schemas.openxmlformats.org/officeDocument/2006/relationships" xmlns:p="http://schemas.openxmlformats.org/presentationml/2006/main" preserve="1">
   <p:cSld name="DEFAULT">
@@ -4041,6 +4130,1129 @@
                 <a:ea typeface="PingFang TC" pitchFamily="34" charset="-122"/>
                 <a:cs typeface="PingFang TC" pitchFamily="34" charset="-120"/>
               </a:rPr>
+              <a:t>DIFFERENTIATION   |   為什麼不直接用 Gemini / ChatGPT？</a:t>
+            </a:r>
+            <a:endParaRPr lang="en-US" sz="1100" dirty="0"/>
+          </a:p>
+        </p:txBody>
+      </p:sp>
+      <p:sp>
+        <p:nvSpPr>
+          <p:cNvPr id="3" name="Text 1"/>
+          <p:cNvSpPr/>
+          <p:nvPr/>
+        </p:nvSpPr>
+        <p:spPr>
+          <a:xfrm>
+            <a:off x="548640" y="640080"/>
+            <a:ext cx="8229600" cy="594360"/>
+          </a:xfrm>
+          <a:prstGeom prst="rect">
+            <a:avLst/>
+          </a:prstGeom>
+          <a:noFill/>
+          <a:ln/>
+        </p:spPr>
+        <p:txBody>
+          <a:bodyPr wrap="square" lIns="0" tIns="0" rIns="0" bIns="0" rtlCol="0" anchor="ctr"/>
+          <a:lstStyle/>
+          <a:p>
+            <a:pPr indent="0" marL="0">
+              <a:buNone/>
+            </a:pPr>
+            <a:r>
+              <a:rPr lang="en-US" sz="3000" b="1" dirty="0">
+                <a:solidFill>
+                  <a:srgbClr val="3D2E20"/>
+                </a:solidFill>
+                <a:latin typeface="PingFang TC" pitchFamily="34" charset="0"/>
+                <a:ea typeface="PingFang TC" pitchFamily="34" charset="-122"/>
+                <a:cs typeface="PingFang TC" pitchFamily="34" charset="-120"/>
+              </a:rPr>
+              <a:t>Gemini 是引擎，暖暖是整台車</a:t>
+            </a:r>
+            <a:endParaRPr lang="en-US" sz="3000" dirty="0"/>
+          </a:p>
+        </p:txBody>
+      </p:sp>
+      <p:sp>
+        <p:nvSpPr>
+          <p:cNvPr id="4" name="Text 2"/>
+          <p:cNvSpPr/>
+          <p:nvPr/>
+        </p:nvSpPr>
+        <p:spPr>
+          <a:xfrm>
+            <a:off x="548640" y="1234440"/>
+            <a:ext cx="8229600" cy="274320"/>
+          </a:xfrm>
+          <a:prstGeom prst="rect">
+            <a:avLst/>
+          </a:prstGeom>
+          <a:noFill/>
+          <a:ln/>
+        </p:spPr>
+        <p:txBody>
+          <a:bodyPr wrap="square" lIns="0" tIns="0" rIns="0" bIns="0" rtlCol="0" anchor="ctr"/>
+          <a:lstStyle/>
+          <a:p>
+            <a:pPr indent="0" marL="0">
+              <a:buNone/>
+            </a:pPr>
+            <a:r>
+              <a:rPr lang="en-US" sz="1300" i="1" dirty="0">
+                <a:solidFill>
+                  <a:srgbClr val="6B5848"/>
+                </a:solidFill>
+                <a:latin typeface="PingFang TC" pitchFamily="34" charset="0"/>
+                <a:ea typeface="PingFang TC" pitchFamily="34" charset="-122"/>
+                <a:cs typeface="PingFang TC" pitchFamily="34" charset="-120"/>
+              </a:rPr>
+              <a:t>引擎再強，沒有方向盤、座椅、安全氣囊 — 長輩不會開、也不敢開</a:t>
+            </a:r>
+            <a:endParaRPr lang="en-US" sz="1300" dirty="0"/>
+          </a:p>
+        </p:txBody>
+      </p:sp>
+      <p:sp>
+        <p:nvSpPr>
+          <p:cNvPr id="5" name="Shape 3"/>
+          <p:cNvSpPr/>
+          <p:nvPr/>
+        </p:nvSpPr>
+        <p:spPr>
+          <a:xfrm>
+            <a:off x="548640" y="1691640"/>
+            <a:ext cx="4023360" cy="411480"/>
+          </a:xfrm>
+          <a:prstGeom prst="roundRect">
+            <a:avLst>
+              <a:gd name="adj" fmla="val 17778"/>
+            </a:avLst>
+          </a:prstGeom>
+          <a:solidFill>
+            <a:srgbClr val="A89580"/>
+          </a:solidFill>
+          <a:ln w="12700">
+            <a:solidFill>
+              <a:srgbClr val="A89580"/>
+            </a:solidFill>
+            <a:prstDash val="solid"/>
+          </a:ln>
+        </p:spPr>
+      </p:sp>
+      <p:sp>
+        <p:nvSpPr>
+          <p:cNvPr id="6" name="Text 4"/>
+          <p:cNvSpPr/>
+          <p:nvPr/>
+        </p:nvSpPr>
+        <p:spPr>
+          <a:xfrm>
+            <a:off x="548640" y="1691640"/>
+            <a:ext cx="4023360" cy="411480"/>
+          </a:xfrm>
+          <a:prstGeom prst="rect">
+            <a:avLst/>
+          </a:prstGeom>
+          <a:noFill/>
+          <a:ln/>
+        </p:spPr>
+        <p:txBody>
+          <a:bodyPr wrap="square" lIns="0" tIns="0" rIns="0" bIns="0" rtlCol="0" anchor="ctr"/>
+          <a:lstStyle/>
+          <a:p>
+            <a:pPr algn="ctr" indent="0" marL="0">
+              <a:buNone/>
+            </a:pPr>
+            <a:r>
+              <a:rPr lang="en-US" sz="1400" b="1" dirty="0">
+                <a:solidFill>
+                  <a:srgbClr val="FFFFFF"/>
+                </a:solidFill>
+                <a:latin typeface="PingFang TC" pitchFamily="34" charset="0"/>
+                <a:ea typeface="PingFang TC" pitchFamily="34" charset="-122"/>
+                <a:cs typeface="PingFang TC" pitchFamily="34" charset="-120"/>
+              </a:rPr>
+              <a:t>直接用 Gemini</a:t>
+            </a:r>
+            <a:endParaRPr lang="en-US" sz="1400" dirty="0"/>
+          </a:p>
+        </p:txBody>
+      </p:sp>
+      <p:sp>
+        <p:nvSpPr>
+          <p:cNvPr id="7" name="Shape 5"/>
+          <p:cNvSpPr/>
+          <p:nvPr/>
+        </p:nvSpPr>
+        <p:spPr>
+          <a:xfrm>
+            <a:off x="4754880" y="1691640"/>
+            <a:ext cx="3840480" cy="411480"/>
+          </a:xfrm>
+          <a:prstGeom prst="roundRect">
+            <a:avLst>
+              <a:gd name="adj" fmla="val 17778"/>
+            </a:avLst>
+          </a:prstGeom>
+          <a:solidFill>
+            <a:srgbClr val="C95E36"/>
+          </a:solidFill>
+          <a:ln w="12700">
+            <a:solidFill>
+              <a:srgbClr val="C95E36"/>
+            </a:solidFill>
+            <a:prstDash val="solid"/>
+          </a:ln>
+        </p:spPr>
+      </p:sp>
+      <p:sp>
+        <p:nvSpPr>
+          <p:cNvPr id="8" name="Text 6"/>
+          <p:cNvSpPr/>
+          <p:nvPr/>
+        </p:nvSpPr>
+        <p:spPr>
+          <a:xfrm>
+            <a:off x="4754880" y="1691640"/>
+            <a:ext cx="3840480" cy="411480"/>
+          </a:xfrm>
+          <a:prstGeom prst="rect">
+            <a:avLst/>
+          </a:prstGeom>
+          <a:noFill/>
+          <a:ln/>
+        </p:spPr>
+        <p:txBody>
+          <a:bodyPr wrap="square" lIns="0" tIns="0" rIns="0" bIns="0" rtlCol="0" anchor="ctr"/>
+          <a:lstStyle/>
+          <a:p>
+            <a:pPr algn="ctr" indent="0" marL="0">
+              <a:buNone/>
+            </a:pPr>
+            <a:r>
+              <a:rPr lang="en-US" sz="1400" b="1" dirty="0">
+                <a:solidFill>
+                  <a:srgbClr val="FFFFFF"/>
+                </a:solidFill>
+                <a:latin typeface="PingFang TC" pitchFamily="34" charset="0"/>
+                <a:ea typeface="PingFang TC" pitchFamily="34" charset="-122"/>
+                <a:cs typeface="PingFang TC" pitchFamily="34" charset="-120"/>
+              </a:rPr>
+              <a:t>🐻  用暖暖</a:t>
+            </a:r>
+            <a:endParaRPr lang="en-US" sz="1400" dirty="0"/>
+          </a:p>
+        </p:txBody>
+      </p:sp>
+      <p:sp>
+        <p:nvSpPr>
+          <p:cNvPr id="9" name="Shape 7"/>
+          <p:cNvSpPr/>
+          <p:nvPr/>
+        </p:nvSpPr>
+        <p:spPr>
+          <a:xfrm>
+            <a:off x="548640" y="2240280"/>
+            <a:ext cx="4023360" cy="548640"/>
+          </a:xfrm>
+          <a:prstGeom prst="rect">
+            <a:avLst/>
+          </a:prstGeom>
+          <a:solidFill>
+            <a:srgbClr val="FFFFFF"/>
+          </a:solidFill>
+          <a:ln w="12700">
+            <a:solidFill>
+              <a:srgbClr val="EDE3D0"/>
+            </a:solidFill>
+            <a:prstDash val="solid"/>
+          </a:ln>
+        </p:spPr>
+      </p:sp>
+      <p:sp>
+        <p:nvSpPr>
+          <p:cNvPr id="10" name="Shape 8"/>
+          <p:cNvSpPr/>
+          <p:nvPr/>
+        </p:nvSpPr>
+        <p:spPr>
+          <a:xfrm>
+            <a:off x="4754880" y="2240280"/>
+            <a:ext cx="3840480" cy="548640"/>
+          </a:xfrm>
+          <a:prstGeom prst="rect">
+            <a:avLst/>
+          </a:prstGeom>
+          <a:solidFill>
+            <a:srgbClr val="FDF1E8"/>
+          </a:solidFill>
+          <a:ln w="12700">
+            <a:solidFill>
+              <a:srgbClr val="E8845A"/>
+            </a:solidFill>
+            <a:prstDash val="solid"/>
+          </a:ln>
+        </p:spPr>
+      </p:sp>
+      <p:sp>
+        <p:nvSpPr>
+          <p:cNvPr id="11" name="Shape 9"/>
+          <p:cNvSpPr/>
+          <p:nvPr/>
+        </p:nvSpPr>
+        <p:spPr>
+          <a:xfrm>
+            <a:off x="4069080" y="2368296"/>
+            <a:ext cx="1005840" cy="292608"/>
+          </a:xfrm>
+          <a:prstGeom prst="roundRect">
+            <a:avLst>
+              <a:gd name="adj" fmla="val 50000"/>
+            </a:avLst>
+          </a:prstGeom>
+          <a:solidFill>
+            <a:srgbClr val="3D2E20"/>
+          </a:solidFill>
+          <a:ln w="12700">
+            <a:solidFill>
+              <a:srgbClr val="3D2E20"/>
+            </a:solidFill>
+            <a:prstDash val="solid"/>
+          </a:ln>
+        </p:spPr>
+      </p:sp>
+      <p:sp>
+        <p:nvSpPr>
+          <p:cNvPr id="12" name="Text 10"/>
+          <p:cNvSpPr/>
+          <p:nvPr/>
+        </p:nvSpPr>
+        <p:spPr>
+          <a:xfrm>
+            <a:off x="4069080" y="2368296"/>
+            <a:ext cx="1005840" cy="292608"/>
+          </a:xfrm>
+          <a:prstGeom prst="rect">
+            <a:avLst/>
+          </a:prstGeom>
+          <a:noFill/>
+          <a:ln/>
+        </p:spPr>
+        <p:txBody>
+          <a:bodyPr wrap="square" lIns="0" tIns="0" rIns="0" bIns="0" rtlCol="0" anchor="ctr"/>
+          <a:lstStyle/>
+          <a:p>
+            <a:pPr algn="ctr" indent="0" marL="0">
+              <a:buNone/>
+            </a:pPr>
+            <a:r>
+              <a:rPr lang="en-US" sz="1000" b="1" dirty="0">
+                <a:solidFill>
+                  <a:srgbClr val="FFFFFF"/>
+                </a:solidFill>
+                <a:latin typeface="PingFang TC" pitchFamily="34" charset="0"/>
+                <a:ea typeface="PingFang TC" pitchFamily="34" charset="-122"/>
+                <a:cs typeface="PingFang TC" pitchFamily="34" charset="-120"/>
+              </a:rPr>
+              <a:t>怎麼操作</a:t>
+            </a:r>
+            <a:endParaRPr lang="en-US" sz="1000" dirty="0"/>
+          </a:p>
+        </p:txBody>
+      </p:sp>
+      <p:sp>
+        <p:nvSpPr>
+          <p:cNvPr id="13" name="Text 11"/>
+          <p:cNvSpPr/>
+          <p:nvPr/>
+        </p:nvSpPr>
+        <p:spPr>
+          <a:xfrm>
+            <a:off x="731520" y="2240280"/>
+            <a:ext cx="3200400" cy="548640"/>
+          </a:xfrm>
+          <a:prstGeom prst="rect">
+            <a:avLst/>
+          </a:prstGeom>
+          <a:noFill/>
+          <a:ln/>
+        </p:spPr>
+        <p:txBody>
+          <a:bodyPr wrap="square" lIns="0" tIns="0" rIns="0" bIns="0" rtlCol="0" anchor="ctr"/>
+          <a:lstStyle/>
+          <a:p>
+            <a:pPr indent="0" marL="0">
+              <a:buNone/>
+            </a:pPr>
+            <a:r>
+              <a:rPr lang="en-US" sz="1200" dirty="0">
+                <a:solidFill>
+                  <a:srgbClr val="6B5848"/>
+                </a:solidFill>
+                <a:latin typeface="PingFang TC" pitchFamily="34" charset="0"/>
+                <a:ea typeface="PingFang TC" pitchFamily="34" charset="-122"/>
+                <a:cs typeface="PingFang TC" pitchFamily="34" charset="-120"/>
+              </a:rPr>
+              <a:t>打字下 prompt、上傳</a:t>
+            </a:r>
+            <a:endParaRPr lang="en-US" sz="1200" dirty="0"/>
+          </a:p>
+        </p:txBody>
+      </p:sp>
+      <p:sp>
+        <p:nvSpPr>
+          <p:cNvPr id="14" name="Text 12"/>
+          <p:cNvSpPr/>
+          <p:nvPr/>
+        </p:nvSpPr>
+        <p:spPr>
+          <a:xfrm>
+            <a:off x="5212080" y="2240280"/>
+            <a:ext cx="3200400" cy="548640"/>
+          </a:xfrm>
+          <a:prstGeom prst="rect">
+            <a:avLst/>
+          </a:prstGeom>
+          <a:noFill/>
+          <a:ln/>
+        </p:spPr>
+        <p:txBody>
+          <a:bodyPr wrap="square" lIns="0" tIns="0" rIns="0" bIns="0" rtlCol="0" anchor="ctr"/>
+          <a:lstStyle/>
+          <a:p>
+            <a:pPr indent="0" marL="0">
+              <a:buNone/>
+            </a:pPr>
+            <a:r>
+              <a:rPr lang="en-US" sz="1200" b="1" dirty="0">
+                <a:solidFill>
+                  <a:srgbClr val="3D2E20"/>
+                </a:solidFill>
+                <a:latin typeface="PingFang TC" pitchFamily="34" charset="0"/>
+                <a:ea typeface="PingFang TC" pitchFamily="34" charset="-122"/>
+                <a:cs typeface="PingFang TC" pitchFamily="34" charset="-120"/>
+              </a:rPr>
+              <a:t>拍一下、按確認</a:t>
+            </a:r>
+            <a:endParaRPr lang="en-US" sz="1200" dirty="0"/>
+          </a:p>
+        </p:txBody>
+      </p:sp>
+      <p:sp>
+        <p:nvSpPr>
+          <p:cNvPr id="15" name="Shape 13"/>
+          <p:cNvSpPr/>
+          <p:nvPr/>
+        </p:nvSpPr>
+        <p:spPr>
+          <a:xfrm>
+            <a:off x="548640" y="2834640"/>
+            <a:ext cx="4023360" cy="548640"/>
+          </a:xfrm>
+          <a:prstGeom prst="rect">
+            <a:avLst/>
+          </a:prstGeom>
+          <a:solidFill>
+            <a:srgbClr val="FFFFFF"/>
+          </a:solidFill>
+          <a:ln w="12700">
+            <a:solidFill>
+              <a:srgbClr val="EDE3D0"/>
+            </a:solidFill>
+            <a:prstDash val="solid"/>
+          </a:ln>
+        </p:spPr>
+      </p:sp>
+      <p:sp>
+        <p:nvSpPr>
+          <p:cNvPr id="16" name="Shape 14"/>
+          <p:cNvSpPr/>
+          <p:nvPr/>
+        </p:nvSpPr>
+        <p:spPr>
+          <a:xfrm>
+            <a:off x="4754880" y="2834640"/>
+            <a:ext cx="3840480" cy="548640"/>
+          </a:xfrm>
+          <a:prstGeom prst="rect">
+            <a:avLst/>
+          </a:prstGeom>
+          <a:solidFill>
+            <a:srgbClr val="FDF1E8"/>
+          </a:solidFill>
+          <a:ln w="12700">
+            <a:solidFill>
+              <a:srgbClr val="E8845A"/>
+            </a:solidFill>
+            <a:prstDash val="solid"/>
+          </a:ln>
+        </p:spPr>
+      </p:sp>
+      <p:sp>
+        <p:nvSpPr>
+          <p:cNvPr id="17" name="Shape 15"/>
+          <p:cNvSpPr/>
+          <p:nvPr/>
+        </p:nvSpPr>
+        <p:spPr>
+          <a:xfrm>
+            <a:off x="4069080" y="2962656"/>
+            <a:ext cx="1005840" cy="292608"/>
+          </a:xfrm>
+          <a:prstGeom prst="roundRect">
+            <a:avLst>
+              <a:gd name="adj" fmla="val 50000"/>
+            </a:avLst>
+          </a:prstGeom>
+          <a:solidFill>
+            <a:srgbClr val="3D2E20"/>
+          </a:solidFill>
+          <a:ln w="12700">
+            <a:solidFill>
+              <a:srgbClr val="3D2E20"/>
+            </a:solidFill>
+            <a:prstDash val="solid"/>
+          </a:ln>
+        </p:spPr>
+      </p:sp>
+      <p:sp>
+        <p:nvSpPr>
+          <p:cNvPr id="18" name="Text 16"/>
+          <p:cNvSpPr/>
+          <p:nvPr/>
+        </p:nvSpPr>
+        <p:spPr>
+          <a:xfrm>
+            <a:off x="4069080" y="2962656"/>
+            <a:ext cx="1005840" cy="292608"/>
+          </a:xfrm>
+          <a:prstGeom prst="rect">
+            <a:avLst/>
+          </a:prstGeom>
+          <a:noFill/>
+          <a:ln/>
+        </p:spPr>
+        <p:txBody>
+          <a:bodyPr wrap="square" lIns="0" tIns="0" rIns="0" bIns="0" rtlCol="0" anchor="ctr"/>
+          <a:lstStyle/>
+          <a:p>
+            <a:pPr algn="ctr" indent="0" marL="0">
+              <a:buNone/>
+            </a:pPr>
+            <a:r>
+              <a:rPr lang="en-US" sz="1000" b="1" dirty="0">
+                <a:solidFill>
+                  <a:srgbClr val="FFFFFF"/>
+                </a:solidFill>
+                <a:latin typeface="PingFang TC" pitchFamily="34" charset="0"/>
+                <a:ea typeface="PingFang TC" pitchFamily="34" charset="-122"/>
+                <a:cs typeface="PingFang TC" pitchFamily="34" charset="-120"/>
+              </a:rPr>
+              <a:t>歷史紀錄</a:t>
+            </a:r>
+            <a:endParaRPr lang="en-US" sz="1000" dirty="0"/>
+          </a:p>
+        </p:txBody>
+      </p:sp>
+      <p:sp>
+        <p:nvSpPr>
+          <p:cNvPr id="19" name="Text 17"/>
+          <p:cNvSpPr/>
+          <p:nvPr/>
+        </p:nvSpPr>
+        <p:spPr>
+          <a:xfrm>
+            <a:off x="731520" y="2834640"/>
+            <a:ext cx="3200400" cy="548640"/>
+          </a:xfrm>
+          <a:prstGeom prst="rect">
+            <a:avLst/>
+          </a:prstGeom>
+          <a:noFill/>
+          <a:ln/>
+        </p:spPr>
+        <p:txBody>
+          <a:bodyPr wrap="square" lIns="0" tIns="0" rIns="0" bIns="0" rtlCol="0" anchor="ctr"/>
+          <a:lstStyle/>
+          <a:p>
+            <a:pPr indent="0" marL="0">
+              <a:buNone/>
+            </a:pPr>
+            <a:r>
+              <a:rPr lang="en-US" sz="1200" dirty="0">
+                <a:solidFill>
+                  <a:srgbClr val="6B5848"/>
+                </a:solidFill>
+                <a:latin typeface="PingFang TC" pitchFamily="34" charset="0"/>
+                <a:ea typeface="PingFang TC" pitchFamily="34" charset="-122"/>
+                <a:cs typeface="PingFang TC" pitchFamily="34" charset="-120"/>
+              </a:rPr>
+              <a:t>❌  沒辦法存</a:t>
+            </a:r>
+            <a:endParaRPr lang="en-US" sz="1200" dirty="0"/>
+          </a:p>
+        </p:txBody>
+      </p:sp>
+      <p:sp>
+        <p:nvSpPr>
+          <p:cNvPr id="20" name="Text 18"/>
+          <p:cNvSpPr/>
+          <p:nvPr/>
+        </p:nvSpPr>
+        <p:spPr>
+          <a:xfrm>
+            <a:off x="5212080" y="2834640"/>
+            <a:ext cx="3200400" cy="548640"/>
+          </a:xfrm>
+          <a:prstGeom prst="rect">
+            <a:avLst/>
+          </a:prstGeom>
+          <a:noFill/>
+          <a:ln/>
+        </p:spPr>
+        <p:txBody>
+          <a:bodyPr wrap="square" lIns="0" tIns="0" rIns="0" bIns="0" rtlCol="0" anchor="ctr"/>
+          <a:lstStyle/>
+          <a:p>
+            <a:pPr indent="0" marL="0">
+              <a:buNone/>
+            </a:pPr>
+            <a:r>
+              <a:rPr lang="en-US" sz="1200" b="1" dirty="0">
+                <a:solidFill>
+                  <a:srgbClr val="3D2E20"/>
+                </a:solidFill>
+                <a:latin typeface="PingFang TC" pitchFamily="34" charset="0"/>
+                <a:ea typeface="PingFang TC" pitchFamily="34" charset="-122"/>
+                <a:cs typeface="PingFang TC" pitchFamily="34" charset="-120"/>
+              </a:rPr>
+              <a:t>✅  自動進飲食日記 + 趨勢圖</a:t>
+            </a:r>
+            <a:endParaRPr lang="en-US" sz="1200" dirty="0"/>
+          </a:p>
+        </p:txBody>
+      </p:sp>
+      <p:sp>
+        <p:nvSpPr>
+          <p:cNvPr id="21" name="Shape 19"/>
+          <p:cNvSpPr/>
+          <p:nvPr/>
+        </p:nvSpPr>
+        <p:spPr>
+          <a:xfrm>
+            <a:off x="548640" y="3429000"/>
+            <a:ext cx="4023360" cy="548640"/>
+          </a:xfrm>
+          <a:prstGeom prst="rect">
+            <a:avLst/>
+          </a:prstGeom>
+          <a:solidFill>
+            <a:srgbClr val="FFFFFF"/>
+          </a:solidFill>
+          <a:ln w="12700">
+            <a:solidFill>
+              <a:srgbClr val="EDE3D0"/>
+            </a:solidFill>
+            <a:prstDash val="solid"/>
+          </a:ln>
+        </p:spPr>
+      </p:sp>
+      <p:sp>
+        <p:nvSpPr>
+          <p:cNvPr id="22" name="Shape 20"/>
+          <p:cNvSpPr/>
+          <p:nvPr/>
+        </p:nvSpPr>
+        <p:spPr>
+          <a:xfrm>
+            <a:off x="4754880" y="3429000"/>
+            <a:ext cx="3840480" cy="548640"/>
+          </a:xfrm>
+          <a:prstGeom prst="rect">
+            <a:avLst/>
+          </a:prstGeom>
+          <a:solidFill>
+            <a:srgbClr val="FDF1E8"/>
+          </a:solidFill>
+          <a:ln w="12700">
+            <a:solidFill>
+              <a:srgbClr val="E8845A"/>
+            </a:solidFill>
+            <a:prstDash val="solid"/>
+          </a:ln>
+        </p:spPr>
+      </p:sp>
+      <p:sp>
+        <p:nvSpPr>
+          <p:cNvPr id="23" name="Shape 21"/>
+          <p:cNvSpPr/>
+          <p:nvPr/>
+        </p:nvSpPr>
+        <p:spPr>
+          <a:xfrm>
+            <a:off x="4069080" y="3557016"/>
+            <a:ext cx="1005840" cy="292608"/>
+          </a:xfrm>
+          <a:prstGeom prst="roundRect">
+            <a:avLst>
+              <a:gd name="adj" fmla="val 50000"/>
+            </a:avLst>
+          </a:prstGeom>
+          <a:solidFill>
+            <a:srgbClr val="3D2E20"/>
+          </a:solidFill>
+          <a:ln w="12700">
+            <a:solidFill>
+              <a:srgbClr val="3D2E20"/>
+            </a:solidFill>
+            <a:prstDash val="solid"/>
+          </a:ln>
+        </p:spPr>
+      </p:sp>
+      <p:sp>
+        <p:nvSpPr>
+          <p:cNvPr id="24" name="Text 22"/>
+          <p:cNvSpPr/>
+          <p:nvPr/>
+        </p:nvSpPr>
+        <p:spPr>
+          <a:xfrm>
+            <a:off x="4069080" y="3557016"/>
+            <a:ext cx="1005840" cy="292608"/>
+          </a:xfrm>
+          <a:prstGeom prst="rect">
+            <a:avLst/>
+          </a:prstGeom>
+          <a:noFill/>
+          <a:ln/>
+        </p:spPr>
+        <p:txBody>
+          <a:bodyPr wrap="square" lIns="0" tIns="0" rIns="0" bIns="0" rtlCol="0" anchor="ctr"/>
+          <a:lstStyle/>
+          <a:p>
+            <a:pPr algn="ctr" indent="0" marL="0">
+              <a:buNone/>
+            </a:pPr>
+            <a:r>
+              <a:rPr lang="en-US" sz="1000" b="1" dirty="0">
+                <a:solidFill>
+                  <a:srgbClr val="FFFFFF"/>
+                </a:solidFill>
+                <a:latin typeface="PingFang TC" pitchFamily="34" charset="0"/>
+                <a:ea typeface="PingFang TC" pitchFamily="34" charset="-122"/>
+                <a:cs typeface="PingFang TC" pitchFamily="34" charset="-120"/>
+              </a:rPr>
+              <a:t>個人化</a:t>
+            </a:r>
+            <a:endParaRPr lang="en-US" sz="1000" dirty="0"/>
+          </a:p>
+        </p:txBody>
+      </p:sp>
+      <p:sp>
+        <p:nvSpPr>
+          <p:cNvPr id="25" name="Text 23"/>
+          <p:cNvSpPr/>
+          <p:nvPr/>
+        </p:nvSpPr>
+        <p:spPr>
+          <a:xfrm>
+            <a:off x="731520" y="3429000"/>
+            <a:ext cx="3200400" cy="548640"/>
+          </a:xfrm>
+          <a:prstGeom prst="rect">
+            <a:avLst/>
+          </a:prstGeom>
+          <a:noFill/>
+          <a:ln/>
+        </p:spPr>
+        <p:txBody>
+          <a:bodyPr wrap="square" lIns="0" tIns="0" rIns="0" bIns="0" rtlCol="0" anchor="ctr"/>
+          <a:lstStyle/>
+          <a:p>
+            <a:pPr indent="0" marL="0">
+              <a:buNone/>
+            </a:pPr>
+            <a:r>
+              <a:rPr lang="en-US" sz="1200" dirty="0">
+                <a:solidFill>
+                  <a:srgbClr val="6B5848"/>
+                </a:solidFill>
+                <a:latin typeface="PingFang TC" pitchFamily="34" charset="0"/>
+                <a:ea typeface="PingFang TC" pitchFamily="34" charset="-122"/>
+                <a:cs typeface="PingFang TC" pitchFamily="34" charset="-120"/>
+              </a:rPr>
+              <a:t>每次從零，不記得你慢性病</a:t>
+            </a:r>
+            <a:endParaRPr lang="en-US" sz="1200" dirty="0"/>
+          </a:p>
+        </p:txBody>
+      </p:sp>
+      <p:sp>
+        <p:nvSpPr>
+          <p:cNvPr id="26" name="Text 24"/>
+          <p:cNvSpPr/>
+          <p:nvPr/>
+        </p:nvSpPr>
+        <p:spPr>
+          <a:xfrm>
+            <a:off x="5212080" y="3429000"/>
+            <a:ext cx="3200400" cy="548640"/>
+          </a:xfrm>
+          <a:prstGeom prst="rect">
+            <a:avLst/>
+          </a:prstGeom>
+          <a:noFill/>
+          <a:ln/>
+        </p:spPr>
+        <p:txBody>
+          <a:bodyPr wrap="square" lIns="0" tIns="0" rIns="0" bIns="0" rtlCol="0" anchor="ctr"/>
+          <a:lstStyle/>
+          <a:p>
+            <a:pPr indent="0" marL="0">
+              <a:buNone/>
+            </a:pPr>
+            <a:r>
+              <a:rPr lang="en-US" sz="1200" b="1" dirty="0">
+                <a:solidFill>
+                  <a:srgbClr val="3D2E20"/>
+                </a:solidFill>
+                <a:latin typeface="PingFang TC" pitchFamily="34" charset="0"/>
+                <a:ea typeface="PingFang TC" pitchFamily="34" charset="-122"/>
+                <a:cs typeface="PingFang TC" pitchFamily="34" charset="-120"/>
+              </a:rPr>
+              <a:t>✅  記得高血壓 → 客製建議</a:t>
+            </a:r>
+            <a:endParaRPr lang="en-US" sz="1200" dirty="0"/>
+          </a:p>
+        </p:txBody>
+      </p:sp>
+      <p:sp>
+        <p:nvSpPr>
+          <p:cNvPr id="27" name="Shape 25"/>
+          <p:cNvSpPr/>
+          <p:nvPr/>
+        </p:nvSpPr>
+        <p:spPr>
+          <a:xfrm>
+            <a:off x="548640" y="4023360"/>
+            <a:ext cx="4023360" cy="548640"/>
+          </a:xfrm>
+          <a:prstGeom prst="rect">
+            <a:avLst/>
+          </a:prstGeom>
+          <a:solidFill>
+            <a:srgbClr val="FFFFFF"/>
+          </a:solidFill>
+          <a:ln w="12700">
+            <a:solidFill>
+              <a:srgbClr val="EDE3D0"/>
+            </a:solidFill>
+            <a:prstDash val="solid"/>
+          </a:ln>
+        </p:spPr>
+      </p:sp>
+      <p:sp>
+        <p:nvSpPr>
+          <p:cNvPr id="28" name="Shape 26"/>
+          <p:cNvSpPr/>
+          <p:nvPr/>
+        </p:nvSpPr>
+        <p:spPr>
+          <a:xfrm>
+            <a:off x="4754880" y="4023360"/>
+            <a:ext cx="3840480" cy="548640"/>
+          </a:xfrm>
+          <a:prstGeom prst="rect">
+            <a:avLst/>
+          </a:prstGeom>
+          <a:solidFill>
+            <a:srgbClr val="FDF1E8"/>
+          </a:solidFill>
+          <a:ln w="12700">
+            <a:solidFill>
+              <a:srgbClr val="E8845A"/>
+            </a:solidFill>
+            <a:prstDash val="solid"/>
+          </a:ln>
+        </p:spPr>
+      </p:sp>
+      <p:sp>
+        <p:nvSpPr>
+          <p:cNvPr id="29" name="Shape 27"/>
+          <p:cNvSpPr/>
+          <p:nvPr/>
+        </p:nvSpPr>
+        <p:spPr>
+          <a:xfrm>
+            <a:off x="4069080" y="4151376"/>
+            <a:ext cx="1005840" cy="292608"/>
+          </a:xfrm>
+          <a:prstGeom prst="roundRect">
+            <a:avLst>
+              <a:gd name="adj" fmla="val 50000"/>
+            </a:avLst>
+          </a:prstGeom>
+          <a:solidFill>
+            <a:srgbClr val="3D2E20"/>
+          </a:solidFill>
+          <a:ln w="12700">
+            <a:solidFill>
+              <a:srgbClr val="3D2E20"/>
+            </a:solidFill>
+            <a:prstDash val="solid"/>
+          </a:ln>
+        </p:spPr>
+      </p:sp>
+      <p:sp>
+        <p:nvSpPr>
+          <p:cNvPr id="30" name="Text 28"/>
+          <p:cNvSpPr/>
+          <p:nvPr/>
+        </p:nvSpPr>
+        <p:spPr>
+          <a:xfrm>
+            <a:off x="4069080" y="4151376"/>
+            <a:ext cx="1005840" cy="292608"/>
+          </a:xfrm>
+          <a:prstGeom prst="rect">
+            <a:avLst/>
+          </a:prstGeom>
+          <a:noFill/>
+          <a:ln/>
+        </p:spPr>
+        <p:txBody>
+          <a:bodyPr wrap="square" lIns="0" tIns="0" rIns="0" bIns="0" rtlCol="0" anchor="ctr"/>
+          <a:lstStyle/>
+          <a:p>
+            <a:pPr algn="ctr" indent="0" marL="0">
+              <a:buNone/>
+            </a:pPr>
+            <a:r>
+              <a:rPr lang="en-US" sz="1000" b="1" dirty="0">
+                <a:solidFill>
+                  <a:srgbClr val="FFFFFF"/>
+                </a:solidFill>
+                <a:latin typeface="PingFang TC" pitchFamily="34" charset="0"/>
+                <a:ea typeface="PingFang TC" pitchFamily="34" charset="-122"/>
+                <a:cs typeface="PingFang TC" pitchFamily="34" charset="-120"/>
+              </a:rPr>
+              <a:t>家人共享</a:t>
+            </a:r>
+            <a:endParaRPr lang="en-US" sz="1000" dirty="0"/>
+          </a:p>
+        </p:txBody>
+      </p:sp>
+      <p:sp>
+        <p:nvSpPr>
+          <p:cNvPr id="31" name="Text 29"/>
+          <p:cNvSpPr/>
+          <p:nvPr/>
+        </p:nvSpPr>
+        <p:spPr>
+          <a:xfrm>
+            <a:off x="731520" y="4023360"/>
+            <a:ext cx="3200400" cy="548640"/>
+          </a:xfrm>
+          <a:prstGeom prst="rect">
+            <a:avLst/>
+          </a:prstGeom>
+          <a:noFill/>
+          <a:ln/>
+        </p:spPr>
+        <p:txBody>
+          <a:bodyPr wrap="square" lIns="0" tIns="0" rIns="0" bIns="0" rtlCol="0" anchor="ctr"/>
+          <a:lstStyle/>
+          <a:p>
+            <a:pPr indent="0" marL="0">
+              <a:buNone/>
+            </a:pPr>
+            <a:r>
+              <a:rPr lang="en-US" sz="1200" dirty="0">
+                <a:solidFill>
+                  <a:srgbClr val="6B5848"/>
+                </a:solidFill>
+                <a:latin typeface="PingFang TC" pitchFamily="34" charset="0"/>
+                <a:ea typeface="PingFang TC" pitchFamily="34" charset="-122"/>
+                <a:cs typeface="PingFang TC" pitchFamily="34" charset="-120"/>
+              </a:rPr>
+              <a:t>❌  完全沒有</a:t>
+            </a:r>
+            <a:endParaRPr lang="en-US" sz="1200" dirty="0"/>
+          </a:p>
+        </p:txBody>
+      </p:sp>
+      <p:sp>
+        <p:nvSpPr>
+          <p:cNvPr id="32" name="Text 30"/>
+          <p:cNvSpPr/>
+          <p:nvPr/>
+        </p:nvSpPr>
+        <p:spPr>
+          <a:xfrm>
+            <a:off x="5212080" y="4023360"/>
+            <a:ext cx="3200400" cy="548640"/>
+          </a:xfrm>
+          <a:prstGeom prst="rect">
+            <a:avLst/>
+          </a:prstGeom>
+          <a:noFill/>
+          <a:ln/>
+        </p:spPr>
+        <p:txBody>
+          <a:bodyPr wrap="square" lIns="0" tIns="0" rIns="0" bIns="0" rtlCol="0" anchor="ctr"/>
+          <a:lstStyle/>
+          <a:p>
+            <a:pPr indent="0" marL="0">
+              <a:buNone/>
+            </a:pPr>
+            <a:r>
+              <a:rPr lang="en-US" sz="1200" b="1" dirty="0">
+                <a:solidFill>
+                  <a:srgbClr val="3D2E20"/>
+                </a:solidFill>
+                <a:latin typeface="PingFang TC" pitchFamily="34" charset="0"/>
+                <a:ea typeface="PingFang TC" pitchFamily="34" charset="-122"/>
+                <a:cs typeface="PingFang TC" pitchFamily="34" charset="-120"/>
+              </a:rPr>
+              <a:t>✅  子女遠端看吃藥/飲食</a:t>
+            </a:r>
+            <a:endParaRPr lang="en-US" sz="1200" dirty="0"/>
+          </a:p>
+        </p:txBody>
+      </p:sp>
+      <p:sp>
+        <p:nvSpPr>
+          <p:cNvPr id="33" name="Shape 31"/>
+          <p:cNvSpPr/>
+          <p:nvPr/>
+        </p:nvSpPr>
+        <p:spPr>
+          <a:xfrm>
+            <a:off x="548640" y="4572000"/>
+            <a:ext cx="8046720" cy="502920"/>
+          </a:xfrm>
+          <a:prstGeom prst="roundRect">
+            <a:avLst>
+              <a:gd name="adj" fmla="val 21818"/>
+            </a:avLst>
+          </a:prstGeom>
+          <a:solidFill>
+            <a:srgbClr val="3D2E20"/>
+          </a:solidFill>
+          <a:ln w="12700">
+            <a:solidFill>
+              <a:srgbClr val="3D2E20"/>
+            </a:solidFill>
+            <a:prstDash val="solid"/>
+          </a:ln>
+        </p:spPr>
+      </p:sp>
+      <p:sp>
+        <p:nvSpPr>
+          <p:cNvPr id="34" name="Text 32"/>
+          <p:cNvSpPr/>
+          <p:nvPr/>
+        </p:nvSpPr>
+        <p:spPr>
+          <a:xfrm>
+            <a:off x="548640" y="4572000"/>
+            <a:ext cx="8046720" cy="502920"/>
+          </a:xfrm>
+          <a:prstGeom prst="rect">
+            <a:avLst/>
+          </a:prstGeom>
+          <a:noFill/>
+          <a:ln/>
+        </p:spPr>
+        <p:txBody>
+          <a:bodyPr wrap="square" lIns="0" tIns="0" rIns="0" bIns="0" rtlCol="0" anchor="ctr"/>
+          <a:lstStyle/>
+          <a:p>
+            <a:pPr algn="ctr" indent="0" marL="0">
+              <a:buNone/>
+            </a:pPr>
+            <a:r>
+              <a:rPr lang="en-US" sz="1300" b="1" dirty="0">
+                <a:solidFill>
+                  <a:srgbClr val="FFFFFF"/>
+                </a:solidFill>
+                <a:latin typeface="PingFang TC" pitchFamily="34" charset="0"/>
+                <a:ea typeface="PingFang TC" pitchFamily="34" charset="-122"/>
+                <a:cs typeface="PingFang TC" pitchFamily="34" charset="-120"/>
+              </a:rPr>
+              <a:t>暖暖的護城河不是 AI 模型 — 是「把 AI 用對的 6 個月 know-how」</a:t>
+            </a:r>
+            <a:endParaRPr lang="en-US" sz="1300" dirty="0"/>
+          </a:p>
+        </p:txBody>
+      </p:sp>
+    </p:spTree>
+  </p:cSld>
+  <p:clrMapOvr>
+    <a:masterClrMapping/>
+  </p:clrMapOvr>
+</p:sld>
+</file>
+
+<file path=ppt/slides/slide6.xml><?xml version="1.0" encoding="utf-8"?>
+<p:sld xmlns:a="http://schemas.openxmlformats.org/drawingml/2006/main" xmlns:r="http://schemas.openxmlformats.org/officeDocument/2006/relationships" xmlns:p="http://schemas.openxmlformats.org/presentationml/2006/main">
+  <p:cSld name="Slide 6">
+    <p:bg>
+      <p:bgPr>
+        <a:solidFill>
+          <a:srgbClr val="FAF5EC"/>
+        </a:solidFill>
+      </p:bgPr>
+    </p:bg>
+    <p:spTree>
+      <p:nvGrpSpPr>
+        <p:cNvPr id="1" name=""/>
+        <p:cNvGrpSpPr/>
+        <p:nvPr/>
+      </p:nvGrpSpPr>
+      <p:grpSpPr>
+        <a:xfrm>
+          <a:off x="0" y="0"/>
+          <a:ext cx="0" cy="0"/>
+          <a:chOff x="0" y="0"/>
+          <a:chExt cx="0" cy="0"/>
+        </a:xfrm>
+      </p:grpSpPr>
+      <p:sp>
+        <p:nvSpPr>
+          <p:cNvPr id="2" name="Text 0"/>
+          <p:cNvSpPr/>
+          <p:nvPr/>
+        </p:nvSpPr>
+        <p:spPr>
+          <a:xfrm>
+            <a:off x="548640" y="320040"/>
+            <a:ext cx="8229600" cy="274320"/>
+          </a:xfrm>
+          <a:prstGeom prst="rect">
+            <a:avLst/>
+          </a:prstGeom>
+          <a:noFill/>
+          <a:ln/>
+        </p:spPr>
+        <p:txBody>
+          <a:bodyPr wrap="square" lIns="0" tIns="0" rIns="0" bIns="0" rtlCol="0" anchor="ctr"/>
+          <a:lstStyle/>
+          <a:p>
+            <a:pPr indent="0" marL="0">
+              <a:buNone/>
+            </a:pPr>
+            <a:r>
+              <a:rPr lang="en-US" sz="1100" b="1" spc="400" kern="0" dirty="0">
+                <a:solidFill>
+                  <a:srgbClr val="C95E36"/>
+                </a:solidFill>
+                <a:latin typeface="PingFang TC" pitchFamily="34" charset="0"/>
+                <a:ea typeface="PingFang TC" pitchFamily="34" charset="-122"/>
+                <a:cs typeface="PingFang TC" pitchFamily="34" charset="-120"/>
+              </a:rPr>
               <a:t>PARTNERSHIP   |   三種彈性合作模式</a:t>
             </a:r>
             <a:endParaRPr lang="en-US" sz="1100" dirty="0"/>
@@ -5270,9 +6482,9 @@
 </p:sld>
 </file>
 
-<file path=ppt/slides/slide6.xml><?xml version="1.0" encoding="utf-8"?>
+<file path=ppt/slides/slide7.xml><?xml version="1.0" encoding="utf-8"?>
 <p:sld xmlns:a="http://schemas.openxmlformats.org/drawingml/2006/main" xmlns:r="http://schemas.openxmlformats.org/officeDocument/2006/relationships" xmlns:p="http://schemas.openxmlformats.org/presentationml/2006/main">
-  <p:cSld name="Slide 6">
+  <p:cSld name="Slide 7">
     <p:bg>
       <p:bgPr>
         <a:solidFill>

</xml_diff>

<commit_message>
feat: highlight voice mode differentiation on solution slide
Emphasize the voice card with:
- Deep orange left accent bar
- '獨家' (Exclusive) badge top-right
- New copy: 'Recognizes name, knows chronic conditions — 3 personalities'
- Subtitle: 'Like family / nurse / grandchild' (in deep orange)

Reinforces the memory + personality angle without adding a new slide.
</commit_message>
<xml_diff>
--- a/pitch/暖暖-通路招商-5min.pptx
+++ b/pitch/暖暖-通路招商-5min.pptx
@@ -3203,6 +3203,97 @@
         </p:nvSpPr>
         <p:spPr>
           <a:xfrm>
+            <a:off x="6217920" y="1463040"/>
+            <a:ext cx="73152" cy="2103120"/>
+          </a:xfrm>
+          <a:prstGeom prst="rect">
+            <a:avLst/>
+          </a:prstGeom>
+          <a:solidFill>
+            <a:srgbClr val="C95E36"/>
+          </a:solidFill>
+          <a:ln w="12700">
+            <a:solidFill>
+              <a:srgbClr val="C95E36"/>
+            </a:solidFill>
+            <a:prstDash val="solid"/>
+          </a:ln>
+        </p:spPr>
+      </p:sp>
+      <p:sp>
+        <p:nvSpPr>
+          <p:cNvPr id="18" name="Shape 16"/>
+          <p:cNvSpPr/>
+          <p:nvPr/>
+        </p:nvSpPr>
+        <p:spPr>
+          <a:xfrm>
+            <a:off x="8138160" y="1572768"/>
+            <a:ext cx="594360" cy="256032"/>
+          </a:xfrm>
+          <a:prstGeom prst="roundRect">
+            <a:avLst>
+              <a:gd name="adj" fmla="val 14286"/>
+            </a:avLst>
+          </a:prstGeom>
+          <a:solidFill>
+            <a:srgbClr val="C95E36"/>
+          </a:solidFill>
+          <a:ln w="12700">
+            <a:solidFill>
+              <a:srgbClr val="C95E36"/>
+            </a:solidFill>
+            <a:prstDash val="solid"/>
+          </a:ln>
+        </p:spPr>
+      </p:sp>
+      <p:sp>
+        <p:nvSpPr>
+          <p:cNvPr id="19" name="Text 17"/>
+          <p:cNvSpPr/>
+          <p:nvPr/>
+        </p:nvSpPr>
+        <p:spPr>
+          <a:xfrm>
+            <a:off x="8138160" y="1572768"/>
+            <a:ext cx="594360" cy="256032"/>
+          </a:xfrm>
+          <a:prstGeom prst="rect">
+            <a:avLst/>
+          </a:prstGeom>
+          <a:noFill/>
+          <a:ln/>
+        </p:spPr>
+        <p:txBody>
+          <a:bodyPr wrap="square" lIns="0" tIns="0" rIns="0" bIns="0" rtlCol="0" anchor="ctr"/>
+          <a:lstStyle/>
+          <a:p>
+            <a:pPr algn="ctr" indent="0" marL="0">
+              <a:buNone/>
+            </a:pPr>
+            <a:r>
+              <a:rPr lang="en-US" sz="1000" b="1" dirty="0">
+                <a:solidFill>
+                  <a:srgbClr val="FFFFFF"/>
+                </a:solidFill>
+                <a:latin typeface="PingFang TC" pitchFamily="34" charset="0"/>
+                <a:ea typeface="PingFang TC" pitchFamily="34" charset="-122"/>
+                <a:cs typeface="PingFang TC" pitchFamily="34" charset="-120"/>
+              </a:rPr>
+              <a:t>獨家</a:t>
+            </a:r>
+            <a:endParaRPr lang="en-US" sz="1000" dirty="0"/>
+          </a:p>
+        </p:txBody>
+      </p:sp>
+      <p:sp>
+        <p:nvSpPr>
+          <p:cNvPr id="20" name="Shape 18"/>
+          <p:cNvSpPr/>
+          <p:nvPr/>
+        </p:nvSpPr>
+        <p:spPr>
+          <a:xfrm>
             <a:off x="7200900" y="1645920"/>
             <a:ext cx="640080" cy="640080"/>
           </a:xfrm>
@@ -3222,7 +3313,7 @@
       </p:sp>
       <p:sp>
         <p:nvSpPr>
-          <p:cNvPr id="18" name="Text 16"/>
+          <p:cNvPr id="21" name="Text 19"/>
           <p:cNvSpPr/>
           <p:nvPr/>
         </p:nvSpPr>
@@ -3261,7 +3352,7 @@
       </p:sp>
       <p:sp>
         <p:nvSpPr>
-          <p:cNvPr id="19" name="Text 17"/>
+          <p:cNvPr id="22" name="Text 20"/>
           <p:cNvSpPr/>
           <p:nvPr/>
         </p:nvSpPr>
@@ -3300,7 +3391,7 @@
       </p:sp>
       <p:sp>
         <p:nvSpPr>
-          <p:cNvPr id="20" name="Text 18"/>
+          <p:cNvPr id="23" name="Text 21"/>
           <p:cNvSpPr/>
           <p:nvPr/>
         </p:nvSpPr>
@@ -3331,7 +3422,7 @@
                 <a:ea typeface="PingFang TC" pitchFamily="34" charset="-122"/>
                 <a:cs typeface="PingFang TC" pitchFamily="34" charset="-120"/>
               </a:rPr>
-              <a:t>中文語音對話，心情陪伴 + 健康問答</a:t>
+              <a:t>認得名字、記得慢性病 — 3 種人格可選</a:t>
             </a:r>
             <a:endParaRPr lang="en-US" sz="1200" dirty="0"/>
           </a:p>
@@ -3339,7 +3430,7 @@
       </p:sp>
       <p:sp>
         <p:nvSpPr>
-          <p:cNvPr id="21" name="Text 19"/>
+          <p:cNvPr id="24" name="Text 22"/>
           <p:cNvSpPr/>
           <p:nvPr/>
         </p:nvSpPr>
@@ -3362,15 +3453,15 @@
               <a:buNone/>
             </a:pPr>
             <a:r>
-              <a:rPr lang="en-US" sz="1000" i="1" dirty="0">
-                <a:solidFill>
-                  <a:srgbClr val="A89580"/>
-                </a:solidFill>
-                <a:latin typeface="PingFang TC" pitchFamily="34" charset="0"/>
-                <a:ea typeface="PingFang TC" pitchFamily="34" charset="-122"/>
-                <a:cs typeface="PingFang TC" pitchFamily="34" charset="-120"/>
-              </a:rPr>
-              <a:t>像跟孫子聊天</a:t>
+              <a:rPr lang="en-US" sz="1000" b="1" i="1" dirty="0">
+                <a:solidFill>
+                  <a:srgbClr val="C95E36"/>
+                </a:solidFill>
+                <a:latin typeface="PingFang TC" pitchFamily="34" charset="0"/>
+                <a:ea typeface="PingFang TC" pitchFamily="34" charset="-122"/>
+                <a:cs typeface="PingFang TC" pitchFamily="34" charset="-120"/>
+              </a:rPr>
+              <a:t>像家人 · 像護理師 · 像小孫子撒嬌</a:t>
             </a:r>
             <a:endParaRPr lang="en-US" sz="1000" dirty="0"/>
           </a:p>
@@ -3378,7 +3469,7 @@
       </p:sp>
       <p:sp>
         <p:nvSpPr>
-          <p:cNvPr id="22" name="Text 20"/>
+          <p:cNvPr id="25" name="Text 23"/>
           <p:cNvSpPr/>
           <p:nvPr/>
         </p:nvSpPr>
@@ -3417,7 +3508,7 @@
       </p:sp>
       <p:sp>
         <p:nvSpPr>
-          <p:cNvPr id="23" name="Shape 21"/>
+          <p:cNvPr id="26" name="Shape 24"/>
           <p:cNvSpPr/>
           <p:nvPr/>
         </p:nvSpPr>
@@ -3444,7 +3535,7 @@
       </p:sp>
       <p:sp>
         <p:nvSpPr>
-          <p:cNvPr id="24" name="Text 22"/>
+          <p:cNvPr id="27" name="Text 25"/>
           <p:cNvSpPr/>
           <p:nvPr/>
         </p:nvSpPr>
@@ -3483,7 +3574,7 @@
       </p:sp>
       <p:sp>
         <p:nvSpPr>
-          <p:cNvPr id="25" name="Shape 23"/>
+          <p:cNvPr id="28" name="Shape 26"/>
           <p:cNvSpPr/>
           <p:nvPr/>
         </p:nvSpPr>
@@ -3510,7 +3601,7 @@
       </p:sp>
       <p:sp>
         <p:nvSpPr>
-          <p:cNvPr id="26" name="Text 24"/>
+          <p:cNvPr id="29" name="Text 27"/>
           <p:cNvSpPr/>
           <p:nvPr/>
         </p:nvSpPr>
@@ -3549,7 +3640,7 @@
       </p:sp>
       <p:sp>
         <p:nvSpPr>
-          <p:cNvPr id="27" name="Shape 25"/>
+          <p:cNvPr id="30" name="Shape 28"/>
           <p:cNvSpPr/>
           <p:nvPr/>
         </p:nvSpPr>
@@ -3576,7 +3667,7 @@
       </p:sp>
       <p:sp>
         <p:nvSpPr>
-          <p:cNvPr id="28" name="Text 26"/>
+          <p:cNvPr id="31" name="Text 29"/>
           <p:cNvSpPr/>
           <p:nvPr/>
         </p:nvSpPr>
@@ -3615,7 +3706,7 @@
       </p:sp>
       <p:sp>
         <p:nvSpPr>
-          <p:cNvPr id="29" name="Shape 27"/>
+          <p:cNvPr id="32" name="Shape 30"/>
           <p:cNvSpPr/>
           <p:nvPr/>
         </p:nvSpPr>
@@ -3642,7 +3733,7 @@
       </p:sp>
       <p:sp>
         <p:nvSpPr>
-          <p:cNvPr id="30" name="Text 28"/>
+          <p:cNvPr id="33" name="Text 31"/>
           <p:cNvSpPr/>
           <p:nvPr/>
         </p:nvSpPr>
@@ -3681,7 +3772,7 @@
       </p:sp>
       <p:sp>
         <p:nvSpPr>
-          <p:cNvPr id="31" name="Shape 29"/>
+          <p:cNvPr id="34" name="Shape 32"/>
           <p:cNvSpPr/>
           <p:nvPr/>
         </p:nvSpPr>
@@ -3708,7 +3799,7 @@
       </p:sp>
       <p:sp>
         <p:nvSpPr>
-          <p:cNvPr id="32" name="Text 30"/>
+          <p:cNvPr id="35" name="Text 33"/>
           <p:cNvSpPr/>
           <p:nvPr/>
         </p:nvSpPr>
@@ -3747,7 +3838,7 @@
       </p:sp>
       <p:sp>
         <p:nvSpPr>
-          <p:cNvPr id="33" name="Text 31"/>
+          <p:cNvPr id="36" name="Text 34"/>
           <p:cNvSpPr/>
           <p:nvPr/>
         </p:nvSpPr>

</xml_diff>

<commit_message>
feat: add proactive guardian vision slide (slide 7)
Dark-themed vision slide showing the roadmap from 'health logging' to
'proactive guardianship': anomaly alerts (LIVE), voice weekly report
(in dev), proactive check-in calls (roadmap). Positions early partners
as co-participants in the guardian roadmap. Deck now 8 slides.

CTA renumbered to slide 8.
</commit_message>
<xml_diff>
--- a/pitch/暖暖-通路招商-5min.pptx
+++ b/pitch/暖暖-通路招商-5min.pptx
@@ -12,9 +12,10 @@
     <p:sldId id="260" r:id="rId6"/>
     <p:sldId id="261" r:id="rId7"/>
     <p:sldId id="262" r:id="rId8"/>
+    <p:sldId id="263" r:id="rId9"/>
   </p:sldIdLst>
   <p:notesMasterIdLst>
-    <p:notesMasterId r:id="rId9"/>
+    <p:notesMasterId r:id="rId10"/>
   </p:notesMasterIdLst>
   <p:sldSz cx="9144000" cy="5143500"/>
   <p:notesSz cx="5143500" cy="9144000"/>
@@ -1078,6 +1079,94 @@
 </p:notes>
 </file>
 
+<file path=ppt/notesSlides/notesSlide8.xml><?xml version="1.0" encoding="utf-8"?>
+<p:notes xmlns:a="http://schemas.openxmlformats.org/drawingml/2006/main" xmlns:r="http://schemas.openxmlformats.org/officeDocument/2006/relationships" xmlns:p="http://schemas.openxmlformats.org/presentationml/2006/main">
+  <p:cSld>
+    <p:spTree>
+      <p:nvGrpSpPr>
+        <p:cNvPr id="1" name=""/>
+        <p:cNvGrpSpPr/>
+        <p:nvPr/>
+      </p:nvGrpSpPr>
+      <p:grpSpPr>
+        <a:xfrm>
+          <a:off x="0" y="0"/>
+          <a:ext cx="0" cy="0"/>
+          <a:chOff x="0" y="0"/>
+          <a:chExt cx="0" cy="0"/>
+        </a:xfrm>
+      </p:grpSpPr>
+      <p:sp>
+        <p:nvSpPr>
+          <p:cNvPr id="2" name="Slide Image Placeholder 1"/>
+          <p:cNvSpPr>
+            <a:spLocks noGrp="1" noRot="1" noChangeAspect="1"/>
+          </p:cNvSpPr>
+          <p:nvPr>
+            <p:ph type="sldImg"/>
+          </p:nvPr>
+        </p:nvSpPr>
+        <p:spPr/>
+      </p:sp>
+      <p:sp>
+        <p:nvSpPr>
+          <p:cNvPr id="3" name="Notes Placeholder 2"/>
+          <p:cNvSpPr>
+            <a:spLocks noGrp="1"/>
+          </p:cNvSpPr>
+          <p:nvPr>
+            <p:ph type="body" idx="1"/>
+          </p:nvPr>
+        </p:nvSpPr>
+        <p:spPr/>
+        <p:txBody>
+          <a:bodyPr/>
+          <a:lstStyle/>
+          <a:p>
+            <a:r>
+              <a:rPr lang="en-US" dirty="0"/>
+              <a:t/>
+            </a:r>
+            <a:endParaRPr lang="en-US" dirty="0"/>
+          </a:p>
+        </p:txBody>
+      </p:sp>
+      <p:sp>
+        <p:nvSpPr>
+          <p:cNvPr id="4" name="Slide Number Placeholder 3"/>
+          <p:cNvSpPr>
+            <a:spLocks noGrp="1"/>
+          </p:cNvSpPr>
+          <p:nvPr>
+            <p:ph type="sldNum" sz="quarter" idx="10"/>
+          </p:nvPr>
+        </p:nvSpPr>
+        <p:spPr/>
+        <p:txBody>
+          <a:bodyPr/>
+          <a:lstStyle/>
+          <a:p>
+            <a:fld id="{F7021451-1387-4CA6-816F-3879F97B5CBC}" type="slidenum">
+              <a:rPr lang="en-US"/>
+              <a:t>8</a:t>
+            </a:fld>
+            <a:endParaRPr lang="en-US"/>
+          </a:p>
+        </p:txBody>
+      </p:sp>
+    </p:spTree>
+    <p:extLst>
+      <p:ext uri="{BB962C8B-B14F-4D97-AF65-F5344CB8AC3E}">
+        <p14:creationId xmlns:p14="http://schemas.microsoft.com/office/powerpoint/2010/main" val="1024086991"/>
+      </p:ext>
+    </p:extLst>
+  </p:cSld>
+  <p:clrMapOvr>
+    <a:masterClrMapping/>
+  </p:clrMapOvr>
+</p:notes>
+</file>
+
 <file path=ppt/slideLayouts/slideLayout1.xml><?xml version="1.0" encoding="utf-8"?>
 <p:sldLayout xmlns:a="http://schemas.openxmlformats.org/drawingml/2006/main" xmlns:r="http://schemas.openxmlformats.org/officeDocument/2006/relationships" xmlns:p="http://schemas.openxmlformats.org/presentationml/2006/main" preserve="1">
   <p:cSld name="DEFAULT">
@@ -6576,6 +6665,818 @@
 <file path=ppt/slides/slide7.xml><?xml version="1.0" encoding="utf-8"?>
 <p:sld xmlns:a="http://schemas.openxmlformats.org/drawingml/2006/main" xmlns:r="http://schemas.openxmlformats.org/officeDocument/2006/relationships" xmlns:p="http://schemas.openxmlformats.org/presentationml/2006/main">
   <p:cSld name="Slide 7">
+    <p:bg>
+      <p:bgPr>
+        <a:solidFill>
+          <a:srgbClr val="3D2E20"/>
+        </a:solidFill>
+      </p:bgPr>
+    </p:bg>
+    <p:spTree>
+      <p:nvGrpSpPr>
+        <p:cNvPr id="1" name=""/>
+        <p:cNvGrpSpPr/>
+        <p:nvPr/>
+      </p:nvGrpSpPr>
+      <p:grpSpPr>
+        <a:xfrm>
+          <a:off x="0" y="0"/>
+          <a:ext cx="0" cy="0"/>
+          <a:chOff x="0" y="0"/>
+          <a:chExt cx="0" cy="0"/>
+        </a:xfrm>
+      </p:grpSpPr>
+      <p:sp>
+        <p:nvSpPr>
+          <p:cNvPr id="2" name="Shape 0"/>
+          <p:cNvSpPr/>
+          <p:nvPr/>
+        </p:nvSpPr>
+        <p:spPr>
+          <a:xfrm>
+            <a:off x="-2286000" y="2286000"/>
+            <a:ext cx="6400800" cy="6400800"/>
+          </a:xfrm>
+          <a:prstGeom prst="ellipse">
+            <a:avLst/>
+          </a:prstGeom>
+          <a:solidFill>
+            <a:srgbClr val="C95E36">
+              <a:alpha val="20000"/>
+            </a:srgbClr>
+          </a:solidFill>
+          <a:ln w="12700">
+            <a:solidFill>
+              <a:srgbClr val="C95E36"/>
+            </a:solidFill>
+            <a:prstDash val="solid"/>
+          </a:ln>
+        </p:spPr>
+      </p:sp>
+      <p:sp>
+        <p:nvSpPr>
+          <p:cNvPr id="3" name="Shape 1"/>
+          <p:cNvSpPr/>
+          <p:nvPr/>
+        </p:nvSpPr>
+        <p:spPr>
+          <a:xfrm>
+            <a:off x="6400800" y="-2286000"/>
+            <a:ext cx="5486400" cy="5486400"/>
+          </a:xfrm>
+          <a:prstGeom prst="ellipse">
+            <a:avLst/>
+          </a:prstGeom>
+          <a:solidFill>
+            <a:srgbClr val="E8845A">
+              <a:alpha val="18000"/>
+            </a:srgbClr>
+          </a:solidFill>
+          <a:ln w="12700">
+            <a:solidFill>
+              <a:srgbClr val="E8845A"/>
+            </a:solidFill>
+            <a:prstDash val="solid"/>
+          </a:ln>
+        </p:spPr>
+      </p:sp>
+      <p:sp>
+        <p:nvSpPr>
+          <p:cNvPr id="4" name="Text 2"/>
+          <p:cNvSpPr/>
+          <p:nvPr/>
+        </p:nvSpPr>
+        <p:spPr>
+          <a:xfrm>
+            <a:off x="548640" y="365760"/>
+            <a:ext cx="8229600" cy="274320"/>
+          </a:xfrm>
+          <a:prstGeom prst="rect">
+            <a:avLst/>
+          </a:prstGeom>
+          <a:noFill/>
+          <a:ln/>
+        </p:spPr>
+        <p:txBody>
+          <a:bodyPr wrap="square" lIns="0" tIns="0" rIns="0" bIns="0" rtlCol="0" anchor="ctr"/>
+          <a:lstStyle/>
+          <a:p>
+            <a:pPr indent="0" marL="0">
+              <a:buNone/>
+            </a:pPr>
+            <a:r>
+              <a:rPr lang="en-US" sz="1100" b="1" spc="400" kern="0" dirty="0">
+                <a:solidFill>
+                  <a:srgbClr val="E8845A"/>
+                </a:solidFill>
+                <a:latin typeface="PingFang TC" pitchFamily="34" charset="0"/>
+                <a:ea typeface="PingFang TC" pitchFamily="34" charset="-122"/>
+                <a:cs typeface="PingFang TC" pitchFamily="34" charset="-120"/>
+              </a:rPr>
+              <a:t>VISION   |   不只記錄，而是主動守護</a:t>
+            </a:r>
+            <a:endParaRPr lang="en-US" sz="1100" dirty="0"/>
+          </a:p>
+        </p:txBody>
+      </p:sp>
+      <p:sp>
+        <p:nvSpPr>
+          <p:cNvPr id="5" name="Text 3"/>
+          <p:cNvSpPr/>
+          <p:nvPr/>
+        </p:nvSpPr>
+        <p:spPr>
+          <a:xfrm>
+            <a:off x="548640" y="685800"/>
+            <a:ext cx="8229600" cy="640080"/>
+          </a:xfrm>
+          <a:prstGeom prst="rect">
+            <a:avLst/>
+          </a:prstGeom>
+          <a:noFill/>
+          <a:ln/>
+        </p:spPr>
+        <p:txBody>
+          <a:bodyPr wrap="square" lIns="0" tIns="0" rIns="0" bIns="0" rtlCol="0" anchor="ctr"/>
+          <a:lstStyle/>
+          <a:p>
+            <a:pPr indent="0" marL="0">
+              <a:buNone/>
+            </a:pPr>
+            <a:r>
+              <a:rPr lang="en-US" sz="3000" b="1" dirty="0">
+                <a:solidFill>
+                  <a:srgbClr val="FFFFFF"/>
+                </a:solidFill>
+                <a:latin typeface="PingFang TC" pitchFamily="34" charset="0"/>
+                <a:ea typeface="PingFang TC" pitchFamily="34" charset="-122"/>
+                <a:cs typeface="PingFang TC" pitchFamily="34" charset="-120"/>
+              </a:rPr>
+              <a:t>從「健康記錄」到「主動守護」</a:t>
+            </a:r>
+            <a:endParaRPr lang="en-US" sz="3000" dirty="0"/>
+          </a:p>
+        </p:txBody>
+      </p:sp>
+      <p:sp>
+        <p:nvSpPr>
+          <p:cNvPr id="6" name="Text 4"/>
+          <p:cNvSpPr/>
+          <p:nvPr/>
+        </p:nvSpPr>
+        <p:spPr>
+          <a:xfrm>
+            <a:off x="548640" y="1298448"/>
+            <a:ext cx="8229600" cy="320040"/>
+          </a:xfrm>
+          <a:prstGeom prst="rect">
+            <a:avLst/>
+          </a:prstGeom>
+          <a:noFill/>
+          <a:ln/>
+        </p:spPr>
+        <p:txBody>
+          <a:bodyPr wrap="square" lIns="0" tIns="0" rIns="0" bIns="0" rtlCol="0" anchor="ctr"/>
+          <a:lstStyle/>
+          <a:p>
+            <a:pPr indent="0" marL="0">
+              <a:buNone/>
+            </a:pPr>
+            <a:r>
+              <a:rPr lang="en-US" sz="1400" i="1" dirty="0">
+                <a:solidFill>
+                  <a:srgbClr val="F2E8D5"/>
+                </a:solidFill>
+                <a:latin typeface="PingFang TC" pitchFamily="34" charset="0"/>
+                <a:ea typeface="PingFang TC" pitchFamily="34" charset="-122"/>
+                <a:cs typeface="PingFang TC" pitchFamily="34" charset="-120"/>
+              </a:rPr>
+              <a:t>我們做的不是健康 App，是讓子女安心的 AI 守護者</a:t>
+            </a:r>
+            <a:endParaRPr lang="en-US" sz="1400" dirty="0"/>
+          </a:p>
+        </p:txBody>
+      </p:sp>
+      <p:sp>
+        <p:nvSpPr>
+          <p:cNvPr id="7" name="Shape 5"/>
+          <p:cNvSpPr/>
+          <p:nvPr/>
+        </p:nvSpPr>
+        <p:spPr>
+          <a:xfrm>
+            <a:off x="548640" y="1828800"/>
+            <a:ext cx="2606040" cy="2286000"/>
+          </a:xfrm>
+          <a:prstGeom prst="roundRect">
+            <a:avLst>
+              <a:gd name="adj" fmla="val 6000"/>
+            </a:avLst>
+          </a:prstGeom>
+          <a:solidFill>
+            <a:srgbClr val="FAF5EC"/>
+          </a:solidFill>
+          <a:ln w="12700">
+            <a:solidFill>
+              <a:srgbClr val="FAF5EC"/>
+            </a:solidFill>
+            <a:prstDash val="solid"/>
+          </a:ln>
+          <a:effectLst>
+            <a:outerShdw sx="100000" sy="100000" kx="0" ky="0" algn="bl" rotWithShape="0" blurRad="127000" dist="38100" dir="5400000">
+              <a:srgbClr val="000000">
+                <a:alpha val="25000"/>
+              </a:srgbClr>
+            </a:outerShdw>
+          </a:effectLst>
+        </p:spPr>
+      </p:sp>
+      <p:sp>
+        <p:nvSpPr>
+          <p:cNvPr id="8" name="Shape 6"/>
+          <p:cNvSpPr/>
+          <p:nvPr/>
+        </p:nvSpPr>
+        <p:spPr>
+          <a:xfrm>
+            <a:off x="777240" y="2057400"/>
+            <a:ext cx="1188720" cy="365760"/>
+          </a:xfrm>
+          <a:prstGeom prst="roundRect">
+            <a:avLst>
+              <a:gd name="adj" fmla="val 50000"/>
+            </a:avLst>
+          </a:prstGeom>
+          <a:solidFill>
+            <a:srgbClr val="7AA779"/>
+          </a:solidFill>
+          <a:ln w="12700">
+            <a:solidFill>
+              <a:srgbClr val="7AA779"/>
+            </a:solidFill>
+            <a:prstDash val="solid"/>
+          </a:ln>
+        </p:spPr>
+      </p:sp>
+      <p:sp>
+        <p:nvSpPr>
+          <p:cNvPr id="9" name="Text 7"/>
+          <p:cNvSpPr/>
+          <p:nvPr/>
+        </p:nvSpPr>
+        <p:spPr>
+          <a:xfrm>
+            <a:off x="777240" y="2057400"/>
+            <a:ext cx="1188720" cy="365760"/>
+          </a:xfrm>
+          <a:prstGeom prst="rect">
+            <a:avLst/>
+          </a:prstGeom>
+          <a:noFill/>
+          <a:ln/>
+        </p:spPr>
+        <p:txBody>
+          <a:bodyPr wrap="square" lIns="0" tIns="0" rIns="0" bIns="0" rtlCol="0" anchor="ctr"/>
+          <a:lstStyle/>
+          <a:p>
+            <a:pPr algn="ctr" indent="0" marL="0">
+              <a:buNone/>
+            </a:pPr>
+            <a:r>
+              <a:rPr lang="en-US" sz="1100" b="1" dirty="0">
+                <a:solidFill>
+                  <a:srgbClr val="FFFFFF"/>
+                </a:solidFill>
+                <a:latin typeface="PingFang TC" pitchFamily="34" charset="0"/>
+                <a:ea typeface="PingFang TC" pitchFamily="34" charset="-122"/>
+                <a:cs typeface="PingFang TC" pitchFamily="34" charset="-120"/>
+              </a:rPr>
+              <a:t>✅ 已上線</a:t>
+            </a:r>
+            <a:endParaRPr lang="en-US" sz="1100" dirty="0"/>
+          </a:p>
+        </p:txBody>
+      </p:sp>
+      <p:sp>
+        <p:nvSpPr>
+          <p:cNvPr id="10" name="Text 8"/>
+          <p:cNvSpPr/>
+          <p:nvPr/>
+        </p:nvSpPr>
+        <p:spPr>
+          <a:xfrm>
+            <a:off x="777240" y="2606040"/>
+            <a:ext cx="2148840" cy="457200"/>
+          </a:xfrm>
+          <a:prstGeom prst="rect">
+            <a:avLst/>
+          </a:prstGeom>
+          <a:noFill/>
+          <a:ln/>
+        </p:spPr>
+        <p:txBody>
+          <a:bodyPr wrap="square" lIns="0" tIns="0" rIns="0" bIns="0" rtlCol="0" anchor="ctr"/>
+          <a:lstStyle/>
+          <a:p>
+            <a:pPr indent="0" marL="0">
+              <a:buNone/>
+            </a:pPr>
+            <a:r>
+              <a:rPr lang="en-US" sz="2100" b="1" dirty="0">
+                <a:solidFill>
+                  <a:srgbClr val="3D2E20"/>
+                </a:solidFill>
+                <a:latin typeface="PingFang TC" pitchFamily="34" charset="0"/>
+                <a:ea typeface="PingFang TC" pitchFamily="34" charset="-122"/>
+                <a:cs typeface="PingFang TC" pitchFamily="34" charset="-120"/>
+              </a:rPr>
+              <a:t>異常預警</a:t>
+            </a:r>
+            <a:endParaRPr lang="en-US" sz="2100" dirty="0"/>
+          </a:p>
+        </p:txBody>
+      </p:sp>
+      <p:sp>
+        <p:nvSpPr>
+          <p:cNvPr id="11" name="Text 9"/>
+          <p:cNvSpPr/>
+          <p:nvPr/>
+        </p:nvSpPr>
+        <p:spPr>
+          <a:xfrm>
+            <a:off x="777240" y="3108960"/>
+            <a:ext cx="2194560" cy="914400"/>
+          </a:xfrm>
+          <a:prstGeom prst="rect">
+            <a:avLst/>
+          </a:prstGeom>
+          <a:noFill/>
+          <a:ln/>
+        </p:spPr>
+        <p:txBody>
+          <a:bodyPr wrap="square" lIns="0" tIns="0" rIns="0" bIns="0" rtlCol="0" anchor="ctr"/>
+          <a:lstStyle/>
+          <a:p>
+            <a:pPr indent="0" marL="0">
+              <a:lnSpc>
+                <a:spcPts val="1800"/>
+              </a:lnSpc>
+              <a:buNone/>
+            </a:pPr>
+            <a:r>
+              <a:rPr lang="en-US" sz="1250" dirty="0">
+                <a:solidFill>
+                  <a:srgbClr val="6B5848"/>
+                </a:solidFill>
+                <a:latin typeface="PingFang TC" pitchFamily="34" charset="0"/>
+                <a:ea typeface="PingFang TC" pitchFamily="34" charset="-122"/>
+                <a:cs typeface="PingFang TC" pitchFamily="34" charset="-120"/>
+              </a:rPr>
+              <a:t>血壓飆高、3 天失聯、漏吃藥 → 自動 email 通知子女</a:t>
+            </a:r>
+            <a:endParaRPr lang="en-US" sz="1250" dirty="0"/>
+          </a:p>
+        </p:txBody>
+      </p:sp>
+      <p:sp>
+        <p:nvSpPr>
+          <p:cNvPr id="12" name="Shape 10"/>
+          <p:cNvSpPr/>
+          <p:nvPr/>
+        </p:nvSpPr>
+        <p:spPr>
+          <a:xfrm>
+            <a:off x="3383280" y="1828800"/>
+            <a:ext cx="2606040" cy="2286000"/>
+          </a:xfrm>
+          <a:prstGeom prst="roundRect">
+            <a:avLst>
+              <a:gd name="adj" fmla="val 6000"/>
+            </a:avLst>
+          </a:prstGeom>
+          <a:solidFill>
+            <a:srgbClr val="FAF5EC"/>
+          </a:solidFill>
+          <a:ln w="12700">
+            <a:solidFill>
+              <a:srgbClr val="FAF5EC"/>
+            </a:solidFill>
+            <a:prstDash val="solid"/>
+          </a:ln>
+          <a:effectLst>
+            <a:outerShdw sx="100000" sy="100000" kx="0" ky="0" algn="bl" rotWithShape="0" blurRad="127000" dist="38100" dir="5400000">
+              <a:srgbClr val="000000">
+                <a:alpha val="25000"/>
+              </a:srgbClr>
+            </a:outerShdw>
+          </a:effectLst>
+        </p:spPr>
+      </p:sp>
+      <p:sp>
+        <p:nvSpPr>
+          <p:cNvPr id="13" name="Shape 11"/>
+          <p:cNvSpPr/>
+          <p:nvPr/>
+        </p:nvSpPr>
+        <p:spPr>
+          <a:xfrm>
+            <a:off x="3611880" y="2057400"/>
+            <a:ext cx="1188720" cy="365760"/>
+          </a:xfrm>
+          <a:prstGeom prst="roundRect">
+            <a:avLst>
+              <a:gd name="adj" fmla="val 50000"/>
+            </a:avLst>
+          </a:prstGeom>
+          <a:solidFill>
+            <a:srgbClr val="D9A441"/>
+          </a:solidFill>
+          <a:ln w="12700">
+            <a:solidFill>
+              <a:srgbClr val="D9A441"/>
+            </a:solidFill>
+            <a:prstDash val="solid"/>
+          </a:ln>
+        </p:spPr>
+      </p:sp>
+      <p:sp>
+        <p:nvSpPr>
+          <p:cNvPr id="14" name="Text 12"/>
+          <p:cNvSpPr/>
+          <p:nvPr/>
+        </p:nvSpPr>
+        <p:spPr>
+          <a:xfrm>
+            <a:off x="3611880" y="2057400"/>
+            <a:ext cx="1188720" cy="365760"/>
+          </a:xfrm>
+          <a:prstGeom prst="rect">
+            <a:avLst/>
+          </a:prstGeom>
+          <a:noFill/>
+          <a:ln/>
+        </p:spPr>
+        <p:txBody>
+          <a:bodyPr wrap="square" lIns="0" tIns="0" rIns="0" bIns="0" rtlCol="0" anchor="ctr"/>
+          <a:lstStyle/>
+          <a:p>
+            <a:pPr algn="ctr" indent="0" marL="0">
+              <a:buNone/>
+            </a:pPr>
+            <a:r>
+              <a:rPr lang="en-US" sz="1100" b="1" dirty="0">
+                <a:solidFill>
+                  <a:srgbClr val="FFFFFF"/>
+                </a:solidFill>
+                <a:latin typeface="PingFang TC" pitchFamily="34" charset="0"/>
+                <a:ea typeface="PingFang TC" pitchFamily="34" charset="-122"/>
+                <a:cs typeface="PingFang TC" pitchFamily="34" charset="-120"/>
+              </a:rPr>
+              <a:t>開發中</a:t>
+            </a:r>
+            <a:endParaRPr lang="en-US" sz="1100" dirty="0"/>
+          </a:p>
+        </p:txBody>
+      </p:sp>
+      <p:sp>
+        <p:nvSpPr>
+          <p:cNvPr id="15" name="Text 13"/>
+          <p:cNvSpPr/>
+          <p:nvPr/>
+        </p:nvSpPr>
+        <p:spPr>
+          <a:xfrm>
+            <a:off x="3611880" y="2606040"/>
+            <a:ext cx="2148840" cy="457200"/>
+          </a:xfrm>
+          <a:prstGeom prst="rect">
+            <a:avLst/>
+          </a:prstGeom>
+          <a:noFill/>
+          <a:ln/>
+        </p:spPr>
+        <p:txBody>
+          <a:bodyPr wrap="square" lIns="0" tIns="0" rIns="0" bIns="0" rtlCol="0" anchor="ctr"/>
+          <a:lstStyle/>
+          <a:p>
+            <a:pPr indent="0" marL="0">
+              <a:buNone/>
+            </a:pPr>
+            <a:r>
+              <a:rPr lang="en-US" sz="2100" b="1" dirty="0">
+                <a:solidFill>
+                  <a:srgbClr val="3D2E20"/>
+                </a:solidFill>
+                <a:latin typeface="PingFang TC" pitchFamily="34" charset="0"/>
+                <a:ea typeface="PingFang TC" pitchFamily="34" charset="-122"/>
+                <a:cs typeface="PingFang TC" pitchFamily="34" charset="-120"/>
+              </a:rPr>
+              <a:t>語音週報</a:t>
+            </a:r>
+            <a:endParaRPr lang="en-US" sz="2100" dirty="0"/>
+          </a:p>
+        </p:txBody>
+      </p:sp>
+      <p:sp>
+        <p:nvSpPr>
+          <p:cNvPr id="16" name="Text 14"/>
+          <p:cNvSpPr/>
+          <p:nvPr/>
+        </p:nvSpPr>
+        <p:spPr>
+          <a:xfrm>
+            <a:off x="3611880" y="3108960"/>
+            <a:ext cx="2194560" cy="914400"/>
+          </a:xfrm>
+          <a:prstGeom prst="rect">
+            <a:avLst/>
+          </a:prstGeom>
+          <a:noFill/>
+          <a:ln/>
+        </p:spPr>
+        <p:txBody>
+          <a:bodyPr wrap="square" lIns="0" tIns="0" rIns="0" bIns="0" rtlCol="0" anchor="ctr"/>
+          <a:lstStyle/>
+          <a:p>
+            <a:pPr indent="0" marL="0">
+              <a:lnSpc>
+                <a:spcPts val="1800"/>
+              </a:lnSpc>
+              <a:buNone/>
+            </a:pPr>
+            <a:r>
+              <a:rPr lang="en-US" sz="1250" dirty="0">
+                <a:solidFill>
+                  <a:srgbClr val="6B5848"/>
+                </a:solidFill>
+                <a:latin typeface="PingFang TC" pitchFamily="34" charset="0"/>
+                <a:ea typeface="PingFang TC" pitchFamily="34" charset="-122"/>
+                <a:cs typeface="PingFang TC" pitchFamily="34" charset="-120"/>
+              </a:rPr>
+              <a:t>每週用溫暖語音，向子女回報爸媽近況</a:t>
+            </a:r>
+            <a:endParaRPr lang="en-US" sz="1250" dirty="0"/>
+          </a:p>
+        </p:txBody>
+      </p:sp>
+      <p:sp>
+        <p:nvSpPr>
+          <p:cNvPr id="17" name="Shape 15"/>
+          <p:cNvSpPr/>
+          <p:nvPr/>
+        </p:nvSpPr>
+        <p:spPr>
+          <a:xfrm>
+            <a:off x="6217920" y="1828800"/>
+            <a:ext cx="2606040" cy="2286000"/>
+          </a:xfrm>
+          <a:prstGeom prst="roundRect">
+            <a:avLst>
+              <a:gd name="adj" fmla="val 6000"/>
+            </a:avLst>
+          </a:prstGeom>
+          <a:solidFill>
+            <a:srgbClr val="FAF5EC"/>
+          </a:solidFill>
+          <a:ln w="12700">
+            <a:solidFill>
+              <a:srgbClr val="FAF5EC"/>
+            </a:solidFill>
+            <a:prstDash val="solid"/>
+          </a:ln>
+          <a:effectLst>
+            <a:outerShdw sx="100000" sy="100000" kx="0" ky="0" algn="bl" rotWithShape="0" blurRad="127000" dist="38100" dir="5400000">
+              <a:srgbClr val="000000">
+                <a:alpha val="25000"/>
+              </a:srgbClr>
+            </a:outerShdw>
+          </a:effectLst>
+        </p:spPr>
+      </p:sp>
+      <p:sp>
+        <p:nvSpPr>
+          <p:cNvPr id="18" name="Shape 16"/>
+          <p:cNvSpPr/>
+          <p:nvPr/>
+        </p:nvSpPr>
+        <p:spPr>
+          <a:xfrm>
+            <a:off x="6446520" y="2057400"/>
+            <a:ext cx="1188720" cy="365760"/>
+          </a:xfrm>
+          <a:prstGeom prst="roundRect">
+            <a:avLst>
+              <a:gd name="adj" fmla="val 50000"/>
+            </a:avLst>
+          </a:prstGeom>
+          <a:solidFill>
+            <a:srgbClr val="A89580"/>
+          </a:solidFill>
+          <a:ln w="12700">
+            <a:solidFill>
+              <a:srgbClr val="A89580"/>
+            </a:solidFill>
+            <a:prstDash val="solid"/>
+          </a:ln>
+        </p:spPr>
+      </p:sp>
+      <p:sp>
+        <p:nvSpPr>
+          <p:cNvPr id="19" name="Text 17"/>
+          <p:cNvSpPr/>
+          <p:nvPr/>
+        </p:nvSpPr>
+        <p:spPr>
+          <a:xfrm>
+            <a:off x="6446520" y="2057400"/>
+            <a:ext cx="1188720" cy="365760"/>
+          </a:xfrm>
+          <a:prstGeom prst="rect">
+            <a:avLst/>
+          </a:prstGeom>
+          <a:noFill/>
+          <a:ln/>
+        </p:spPr>
+        <p:txBody>
+          <a:bodyPr wrap="square" lIns="0" tIns="0" rIns="0" bIns="0" rtlCol="0" anchor="ctr"/>
+          <a:lstStyle/>
+          <a:p>
+            <a:pPr algn="ctr" indent="0" marL="0">
+              <a:buNone/>
+            </a:pPr>
+            <a:r>
+              <a:rPr lang="en-US" sz="1100" b="1" dirty="0">
+                <a:solidFill>
+                  <a:srgbClr val="FFFFFF"/>
+                </a:solidFill>
+                <a:latin typeface="PingFang TC" pitchFamily="34" charset="0"/>
+                <a:ea typeface="PingFang TC" pitchFamily="34" charset="-122"/>
+                <a:cs typeface="PingFang TC" pitchFamily="34" charset="-120"/>
+              </a:rPr>
+              <a:t>藍圖</a:t>
+            </a:r>
+            <a:endParaRPr lang="en-US" sz="1100" dirty="0"/>
+          </a:p>
+        </p:txBody>
+      </p:sp>
+      <p:sp>
+        <p:nvSpPr>
+          <p:cNvPr id="20" name="Text 18"/>
+          <p:cNvSpPr/>
+          <p:nvPr/>
+        </p:nvSpPr>
+        <p:spPr>
+          <a:xfrm>
+            <a:off x="6446520" y="2606040"/>
+            <a:ext cx="2148840" cy="457200"/>
+          </a:xfrm>
+          <a:prstGeom prst="rect">
+            <a:avLst/>
+          </a:prstGeom>
+          <a:noFill/>
+          <a:ln/>
+        </p:spPr>
+        <p:txBody>
+          <a:bodyPr wrap="square" lIns="0" tIns="0" rIns="0" bIns="0" rtlCol="0" anchor="ctr"/>
+          <a:lstStyle/>
+          <a:p>
+            <a:pPr indent="0" marL="0">
+              <a:buNone/>
+            </a:pPr>
+            <a:r>
+              <a:rPr lang="en-US" sz="2100" b="1" dirty="0">
+                <a:solidFill>
+                  <a:srgbClr val="3D2E20"/>
+                </a:solidFill>
+                <a:latin typeface="PingFang TC" pitchFamily="34" charset="0"/>
+                <a:ea typeface="PingFang TC" pitchFamily="34" charset="-122"/>
+                <a:cs typeface="PingFang TC" pitchFamily="34" charset="-120"/>
+              </a:rPr>
+              <a:t>主動關懷來電</a:t>
+            </a:r>
+            <a:endParaRPr lang="en-US" sz="2100" dirty="0"/>
+          </a:p>
+        </p:txBody>
+      </p:sp>
+      <p:sp>
+        <p:nvSpPr>
+          <p:cNvPr id="21" name="Text 19"/>
+          <p:cNvSpPr/>
+          <p:nvPr/>
+        </p:nvSpPr>
+        <p:spPr>
+          <a:xfrm>
+            <a:off x="6446520" y="3108960"/>
+            <a:ext cx="2194560" cy="914400"/>
+          </a:xfrm>
+          <a:prstGeom prst="rect">
+            <a:avLst/>
+          </a:prstGeom>
+          <a:noFill/>
+          <a:ln/>
+        </p:spPr>
+        <p:txBody>
+          <a:bodyPr wrap="square" lIns="0" tIns="0" rIns="0" bIns="0" rtlCol="0" anchor="ctr"/>
+          <a:lstStyle/>
+          <a:p>
+            <a:pPr indent="0" marL="0">
+              <a:lnSpc>
+                <a:spcPts val="1800"/>
+              </a:lnSpc>
+              <a:buNone/>
+            </a:pPr>
+            <a:r>
+              <a:rPr lang="en-US" sz="1250" dirty="0">
+                <a:solidFill>
+                  <a:srgbClr val="6B5848"/>
+                </a:solidFill>
+                <a:latin typeface="PingFang TC" pitchFamily="34" charset="0"/>
+                <a:ea typeface="PingFang TC" pitchFamily="34" charset="-122"/>
+                <a:cs typeface="PingFang TC" pitchFamily="34" charset="-120"/>
+              </a:rPr>
+              <a:t>暖暖每天主動「打給」長輩問候、提醒</a:t>
+            </a:r>
+            <a:endParaRPr lang="en-US" sz="1250" dirty="0"/>
+          </a:p>
+        </p:txBody>
+      </p:sp>
+      <p:sp>
+        <p:nvSpPr>
+          <p:cNvPr id="22" name="Shape 20"/>
+          <p:cNvSpPr/>
+          <p:nvPr/>
+        </p:nvSpPr>
+        <p:spPr>
+          <a:xfrm>
+            <a:off x="548640" y="4434840"/>
+            <a:ext cx="8046720" cy="502920"/>
+          </a:xfrm>
+          <a:prstGeom prst="roundRect">
+            <a:avLst>
+              <a:gd name="adj" fmla="val 21818"/>
+            </a:avLst>
+          </a:prstGeom>
+          <a:solidFill>
+            <a:srgbClr val="E8845A"/>
+          </a:solidFill>
+          <a:ln w="12700">
+            <a:solidFill>
+              <a:srgbClr val="E8845A"/>
+            </a:solidFill>
+            <a:prstDash val="solid"/>
+          </a:ln>
+        </p:spPr>
+      </p:sp>
+      <p:sp>
+        <p:nvSpPr>
+          <p:cNvPr id="23" name="Text 21"/>
+          <p:cNvSpPr/>
+          <p:nvPr/>
+        </p:nvSpPr>
+        <p:spPr>
+          <a:xfrm>
+            <a:off x="548640" y="4434840"/>
+            <a:ext cx="8046720" cy="502920"/>
+          </a:xfrm>
+          <a:prstGeom prst="rect">
+            <a:avLst/>
+          </a:prstGeom>
+          <a:noFill/>
+          <a:ln/>
+        </p:spPr>
+        <p:txBody>
+          <a:bodyPr wrap="square" lIns="0" tIns="0" rIns="0" bIns="0" rtlCol="0" anchor="ctr"/>
+          <a:lstStyle/>
+          <a:p>
+            <a:pPr algn="ctr" indent="0" marL="0">
+              <a:buNone/>
+            </a:pPr>
+            <a:r>
+              <a:rPr lang="en-US" sz="1400" b="1" dirty="0">
+                <a:solidFill>
+                  <a:srgbClr val="FFFFFF"/>
+                </a:solidFill>
+                <a:latin typeface="PingFang TC" pitchFamily="34" charset="0"/>
+                <a:ea typeface="PingFang TC" pitchFamily="34" charset="-122"/>
+                <a:cs typeface="PingFang TC" pitchFamily="34" charset="-120"/>
+              </a:rPr>
+              <a:t>早期合作的夥伴，會一起參與這個守護藍圖</a:t>
+            </a:r>
+            <a:endParaRPr lang="en-US" sz="1400" dirty="0"/>
+          </a:p>
+        </p:txBody>
+      </p:sp>
+    </p:spTree>
+  </p:cSld>
+  <p:clrMapOvr>
+    <a:masterClrMapping/>
+  </p:clrMapOvr>
+</p:sld>
+</file>
+
+<file path=ppt/slides/slide8.xml><?xml version="1.0" encoding="utf-8"?>
+<p:sld xmlns:a="http://schemas.openxmlformats.org/drawingml/2006/main" xmlns:r="http://schemas.openxmlformats.org/officeDocument/2006/relationships" xmlns:p="http://schemas.openxmlformats.org/presentationml/2006/main">
+  <p:cSld name="Slide 8">
     <p:bg>
       <p:bgPr>
         <a:solidFill>

</xml_diff>

<commit_message>
feat: upgrade vision slide to 3-horizon partner roadmap
Replace the simple vision slide with a strategic 3-horizon roadmap
(H1 Proactive Care / H2 Health Platform / H3 Silver Ecosystem), each
showing status, features, and the partner revenue opportunity at that
stage. Adds 04-願景藍圖.md with full roadmap narrative and pitch script.

Reframes the product as a growing platform — early partners get
priority and better terms at each new stage.
</commit_message>
<xml_diff>
--- a/pitch/暖暖-通路招商-5min.pptx
+++ b/pitch/暖暖-通路招商-5min.pptx
@@ -6748,7 +6748,7 @@
         </p:nvSpPr>
         <p:spPr>
           <a:xfrm>
-            <a:off x="548640" y="365760"/>
+            <a:off x="548640" y="347472"/>
             <a:ext cx="8229600" cy="274320"/>
           </a:xfrm>
           <a:prstGeom prst="rect">
@@ -6773,7 +6773,7 @@
                 <a:ea typeface="PingFang TC" pitchFamily="34" charset="-122"/>
                 <a:cs typeface="PingFang TC" pitchFamily="34" charset="-120"/>
               </a:rPr>
-              <a:t>VISION   |   不只記錄，而是主動守護</a:t>
+              <a:t>ROADMAP   |   一個會越長越大的平台</a:t>
             </a:r>
             <a:endParaRPr lang="en-US" sz="1100" dirty="0"/>
           </a:p>
@@ -6787,8 +6787,8 @@
         </p:nvSpPr>
         <p:spPr>
           <a:xfrm>
-            <a:off x="548640" y="685800"/>
-            <a:ext cx="8229600" cy="640080"/>
+            <a:off x="548640" y="658368"/>
+            <a:ext cx="8229600" cy="548640"/>
           </a:xfrm>
           <a:prstGeom prst="rect">
             <a:avLst/>
@@ -6804,7 +6804,7 @@
               <a:buNone/>
             </a:pPr>
             <a:r>
-              <a:rPr lang="en-US" sz="3000" b="1" dirty="0">
+              <a:rPr lang="en-US" sz="2800" b="1" dirty="0">
                 <a:solidFill>
                   <a:srgbClr val="FFFFFF"/>
                 </a:solidFill>
@@ -6812,9 +6812,9 @@
                 <a:ea typeface="PingFang TC" pitchFamily="34" charset="-122"/>
                 <a:cs typeface="PingFang TC" pitchFamily="34" charset="-120"/>
               </a:rPr>
-              <a:t>從「健康記錄」到「主動守護」</a:t>
-            </a:r>
-            <a:endParaRPr lang="en-US" sz="3000" dirty="0"/>
+              <a:t>從工具，到平台，到生態系</a:t>
+            </a:r>
+            <a:endParaRPr lang="en-US" sz="2800" dirty="0"/>
           </a:p>
         </p:txBody>
       </p:sp>
@@ -6826,8 +6826,8 @@
         </p:nvSpPr>
         <p:spPr>
           <a:xfrm>
-            <a:off x="548640" y="1298448"/>
-            <a:ext cx="8229600" cy="320040"/>
+            <a:off x="548640" y="1234440"/>
+            <a:ext cx="8229600" cy="274320"/>
           </a:xfrm>
           <a:prstGeom prst="rect">
             <a:avLst/>
@@ -6843,7 +6843,7 @@
               <a:buNone/>
             </a:pPr>
             <a:r>
-              <a:rPr lang="en-US" sz="1400" i="1" dirty="0">
+              <a:rPr lang="en-US" sz="1300" i="1" dirty="0">
                 <a:solidFill>
                   <a:srgbClr val="F2E8D5"/>
                 </a:solidFill>
@@ -6851,9 +6851,9 @@
                 <a:ea typeface="PingFang TC" pitchFamily="34" charset="-122"/>
                 <a:cs typeface="PingFang TC" pitchFamily="34" charset="-120"/>
               </a:rPr>
-              <a:t>我們做的不是健康 App，是讓子女安心的 AI 守護者</a:t>
-            </a:r>
-            <a:endParaRPr lang="en-US" sz="1400" dirty="0"/>
+              <a:t>每一階段，都為合作夥伴開出新的賺錢機會</a:t>
+            </a:r>
+            <a:endParaRPr lang="en-US" sz="1300" dirty="0"/>
           </a:p>
         </p:txBody>
       </p:sp>
@@ -6865,12 +6865,12 @@
         </p:nvSpPr>
         <p:spPr>
           <a:xfrm>
-            <a:off x="548640" y="1828800"/>
-            <a:ext cx="2606040" cy="2286000"/>
+            <a:off x="548640" y="1600200"/>
+            <a:ext cx="2606040" cy="2697480"/>
           </a:xfrm>
           <a:prstGeom prst="roundRect">
             <a:avLst>
-              <a:gd name="adj" fmla="val 6000"/>
+              <a:gd name="adj" fmla="val 4211"/>
             </a:avLst>
           </a:prstGeom>
           <a:solidFill>
@@ -6899,13 +6899,11 @@
         </p:nvSpPr>
         <p:spPr>
           <a:xfrm>
-            <a:off x="777240" y="2057400"/>
-            <a:ext cx="1188720" cy="365760"/>
-          </a:xfrm>
-          <a:prstGeom prst="roundRect">
-            <a:avLst>
-              <a:gd name="adj" fmla="val 50000"/>
-            </a:avLst>
+            <a:off x="548640" y="1600200"/>
+            <a:ext cx="2606040" cy="109728"/>
+          </a:xfrm>
+          <a:prstGeom prst="rect">
+            <a:avLst/>
           </a:prstGeom>
           <a:solidFill>
             <a:srgbClr val="7AA779"/>
@@ -6920,138 +6918,348 @@
       </p:sp>
       <p:sp>
         <p:nvSpPr>
-          <p:cNvPr id="9" name="Text 7"/>
-          <p:cNvSpPr/>
-          <p:nvPr/>
-        </p:nvSpPr>
-        <p:spPr>
-          <a:xfrm>
-            <a:off x="777240" y="2057400"/>
-            <a:ext cx="1188720" cy="365760"/>
-          </a:xfrm>
-          <a:prstGeom prst="rect">
-            <a:avLst/>
-          </a:prstGeom>
-          <a:noFill/>
-          <a:ln/>
-        </p:spPr>
-        <p:txBody>
-          <a:bodyPr wrap="square" lIns="0" tIns="0" rIns="0" bIns="0" rtlCol="0" anchor="ctr"/>
-          <a:lstStyle/>
-          <a:p>
-            <a:pPr algn="ctr" indent="0" marL="0">
-              <a:buNone/>
-            </a:pPr>
-            <a:r>
-              <a:rPr lang="en-US" sz="1100" b="1" dirty="0">
-                <a:solidFill>
-                  <a:srgbClr val="FFFFFF"/>
-                </a:solidFill>
-                <a:latin typeface="PingFang TC" pitchFamily="34" charset="0"/>
-                <a:ea typeface="PingFang TC" pitchFamily="34" charset="-122"/>
-                <a:cs typeface="PingFang TC" pitchFamily="34" charset="-120"/>
-              </a:rPr>
-              <a:t>✅ 已上線</a:t>
-            </a:r>
-            <a:endParaRPr lang="en-US" sz="1100" dirty="0"/>
-          </a:p>
-        </p:txBody>
-      </p:sp>
-      <p:sp>
-        <p:nvSpPr>
-          <p:cNvPr id="10" name="Text 8"/>
-          <p:cNvSpPr/>
-          <p:nvPr/>
-        </p:nvSpPr>
-        <p:spPr>
-          <a:xfrm>
-            <a:off x="777240" y="2606040"/>
-            <a:ext cx="2148840" cy="457200"/>
-          </a:xfrm>
-          <a:prstGeom prst="rect">
-            <a:avLst/>
-          </a:prstGeom>
-          <a:noFill/>
-          <a:ln/>
-        </p:spPr>
-        <p:txBody>
-          <a:bodyPr wrap="square" lIns="0" tIns="0" rIns="0" bIns="0" rtlCol="0" anchor="ctr"/>
-          <a:lstStyle/>
-          <a:p>
-            <a:pPr indent="0" marL="0">
-              <a:buNone/>
-            </a:pPr>
-            <a:r>
-              <a:rPr lang="en-US" sz="2100" b="1" dirty="0">
-                <a:solidFill>
-                  <a:srgbClr val="3D2E20"/>
-                </a:solidFill>
-                <a:latin typeface="PingFang TC" pitchFamily="34" charset="0"/>
-                <a:ea typeface="PingFang TC" pitchFamily="34" charset="-122"/>
-                <a:cs typeface="PingFang TC" pitchFamily="34" charset="-120"/>
-              </a:rPr>
-              <a:t>異常預警</a:t>
-            </a:r>
-            <a:endParaRPr lang="en-US" sz="2100" dirty="0"/>
-          </a:p>
-        </p:txBody>
-      </p:sp>
-      <p:sp>
-        <p:nvSpPr>
-          <p:cNvPr id="11" name="Text 9"/>
-          <p:cNvSpPr/>
-          <p:nvPr/>
-        </p:nvSpPr>
-        <p:spPr>
-          <a:xfrm>
-            <a:off x="777240" y="3108960"/>
-            <a:ext cx="2194560" cy="914400"/>
-          </a:xfrm>
-          <a:prstGeom prst="rect">
-            <a:avLst/>
-          </a:prstGeom>
-          <a:noFill/>
-          <a:ln/>
-        </p:spPr>
-        <p:txBody>
-          <a:bodyPr wrap="square" lIns="0" tIns="0" rIns="0" bIns="0" rtlCol="0" anchor="ctr"/>
-          <a:lstStyle/>
-          <a:p>
-            <a:pPr indent="0" marL="0">
-              <a:lnSpc>
-                <a:spcPts val="1800"/>
-              </a:lnSpc>
-              <a:buNone/>
-            </a:pPr>
-            <a:r>
-              <a:rPr lang="en-US" sz="1250" dirty="0">
-                <a:solidFill>
-                  <a:srgbClr val="6B5848"/>
-                </a:solidFill>
-                <a:latin typeface="PingFang TC" pitchFamily="34" charset="0"/>
-                <a:ea typeface="PingFang TC" pitchFamily="34" charset="-122"/>
-                <a:cs typeface="PingFang TC" pitchFamily="34" charset="-120"/>
-              </a:rPr>
-              <a:t>血壓飆高、3 天失聯、漏吃藥 → 自動 email 通知子女</a:t>
-            </a:r>
-            <a:endParaRPr lang="en-US" sz="1250" dirty="0"/>
-          </a:p>
-        </p:txBody>
-      </p:sp>
-      <p:sp>
-        <p:nvSpPr>
-          <p:cNvPr id="12" name="Shape 10"/>
-          <p:cNvSpPr/>
-          <p:nvPr/>
-        </p:nvSpPr>
-        <p:spPr>
-          <a:xfrm>
-            <a:off x="3383280" y="1828800"/>
-            <a:ext cx="2606040" cy="2286000"/>
+          <p:cNvPr id="9" name="Shape 7"/>
+          <p:cNvSpPr/>
+          <p:nvPr/>
+        </p:nvSpPr>
+        <p:spPr>
+          <a:xfrm>
+            <a:off x="731520" y="1828800"/>
+            <a:ext cx="1417320" cy="310896"/>
           </a:xfrm>
           <a:prstGeom prst="roundRect">
             <a:avLst>
-              <a:gd name="adj" fmla="val 6000"/>
+              <a:gd name="adj" fmla="val 50000"/>
+            </a:avLst>
+          </a:prstGeom>
+          <a:solidFill>
+            <a:srgbClr val="7AA779"/>
+          </a:solidFill>
+          <a:ln w="12700">
+            <a:solidFill>
+              <a:srgbClr val="7AA779"/>
+            </a:solidFill>
+            <a:prstDash val="solid"/>
+          </a:ln>
+        </p:spPr>
+      </p:sp>
+      <p:sp>
+        <p:nvSpPr>
+          <p:cNvPr id="10" name="Text 8"/>
+          <p:cNvSpPr/>
+          <p:nvPr/>
+        </p:nvSpPr>
+        <p:spPr>
+          <a:xfrm>
+            <a:off x="731520" y="1828800"/>
+            <a:ext cx="1417320" cy="310896"/>
+          </a:xfrm>
+          <a:prstGeom prst="rect">
+            <a:avLst/>
+          </a:prstGeom>
+          <a:noFill/>
+          <a:ln/>
+        </p:spPr>
+        <p:txBody>
+          <a:bodyPr wrap="square" lIns="0" tIns="0" rIns="0" bIns="0" rtlCol="0" anchor="ctr"/>
+          <a:lstStyle/>
+          <a:p>
+            <a:pPr algn="ctr" indent="0" marL="0">
+              <a:buNone/>
+            </a:pPr>
+            <a:r>
+              <a:rPr lang="en-US" sz="1000" b="1" dirty="0">
+                <a:solidFill>
+                  <a:srgbClr val="FFFFFF"/>
+                </a:solidFill>
+                <a:latin typeface="PingFang TC" pitchFamily="34" charset="0"/>
+                <a:ea typeface="PingFang TC" pitchFamily="34" charset="-122"/>
+                <a:cs typeface="PingFang TC" pitchFamily="34" charset="-120"/>
+              </a:rPr>
+              <a:t>✅ 部分已上線</a:t>
+            </a:r>
+            <a:endParaRPr lang="en-US" sz="1000" dirty="0"/>
+          </a:p>
+        </p:txBody>
+      </p:sp>
+      <p:sp>
+        <p:nvSpPr>
+          <p:cNvPr id="11" name="Text 9"/>
+          <p:cNvSpPr/>
+          <p:nvPr/>
+        </p:nvSpPr>
+        <p:spPr>
+          <a:xfrm>
+            <a:off x="731520" y="2212848"/>
+            <a:ext cx="2240280" cy="320040"/>
+          </a:xfrm>
+          <a:prstGeom prst="rect">
+            <a:avLst/>
+          </a:prstGeom>
+          <a:noFill/>
+          <a:ln/>
+        </p:spPr>
+        <p:txBody>
+          <a:bodyPr wrap="square" lIns="0" tIns="0" rIns="0" bIns="0" rtlCol="0" anchor="ctr"/>
+          <a:lstStyle/>
+          <a:p>
+            <a:pPr indent="0" marL="0">
+              <a:buNone/>
+            </a:pPr>
+            <a:r>
+              <a:rPr lang="en-US" sz="1600" b="1" dirty="0">
+                <a:solidFill>
+                  <a:srgbClr val="3D2E20"/>
+                </a:solidFill>
+                <a:latin typeface="PingFang TC" pitchFamily="34" charset="0"/>
+                <a:ea typeface="PingFang TC" pitchFamily="34" charset="-122"/>
+                <a:cs typeface="PingFang TC" pitchFamily="34" charset="-120"/>
+              </a:rPr>
+              <a:t>H1 · 主動守護</a:t>
+            </a:r>
+            <a:endParaRPr lang="en-US" sz="1600" dirty="0"/>
+          </a:p>
+        </p:txBody>
+      </p:sp>
+      <p:sp>
+        <p:nvSpPr>
+          <p:cNvPr id="12" name="Text 10"/>
+          <p:cNvSpPr/>
+          <p:nvPr/>
+        </p:nvSpPr>
+        <p:spPr>
+          <a:xfrm>
+            <a:off x="731520" y="2523744"/>
+            <a:ext cx="2240280" cy="274320"/>
+          </a:xfrm>
+          <a:prstGeom prst="rect">
+            <a:avLst/>
+          </a:prstGeom>
+          <a:noFill/>
+          <a:ln/>
+        </p:spPr>
+        <p:txBody>
+          <a:bodyPr wrap="square" lIns="0" tIns="0" rIns="0" bIns="0" rtlCol="0" anchor="ctr"/>
+          <a:lstStyle/>
+          <a:p>
+            <a:pPr indent="0" marL="0">
+              <a:buNone/>
+            </a:pPr>
+            <a:r>
+              <a:rPr lang="en-US" sz="1000" dirty="0">
+                <a:solidFill>
+                  <a:srgbClr val="A89580"/>
+                </a:solidFill>
+                <a:latin typeface="PingFang TC" pitchFamily="34" charset="0"/>
+                <a:ea typeface="PingFang TC" pitchFamily="34" charset="-122"/>
+                <a:cs typeface="PingFang TC" pitchFamily="34" charset="-120"/>
+              </a:rPr>
+              <a:t>0–6 個月　</a:t>
+            </a:r>
+            <a:pPr indent="0" marL="0">
+              <a:buNone/>
+            </a:pPr>
+            <a:r>
+              <a:rPr lang="en-US" sz="1100" b="1" dirty="0">
+                <a:solidFill>
+                  <a:srgbClr val="7AA779"/>
+                </a:solidFill>
+                <a:latin typeface="PingFang TC" pitchFamily="34" charset="0"/>
+                <a:ea typeface="PingFang TC" pitchFamily="34" charset="-122"/>
+                <a:cs typeface="PingFang TC" pitchFamily="34" charset="-120"/>
+              </a:rPr>
+              <a:t>讓子女安心</a:t>
+            </a:r>
+            <a:endParaRPr lang="en-US" sz="1000" dirty="0"/>
+          </a:p>
+        </p:txBody>
+      </p:sp>
+      <p:sp>
+        <p:nvSpPr>
+          <p:cNvPr id="13" name="Text 11"/>
+          <p:cNvSpPr/>
+          <p:nvPr/>
+        </p:nvSpPr>
+        <p:spPr>
+          <a:xfrm>
+            <a:off x="777240" y="2852928"/>
+            <a:ext cx="2194560" cy="960120"/>
+          </a:xfrm>
+          <a:prstGeom prst="rect">
+            <a:avLst/>
+          </a:prstGeom>
+          <a:noFill/>
+          <a:ln/>
+        </p:spPr>
+        <p:txBody>
+          <a:bodyPr wrap="square" lIns="0" tIns="0" rIns="0" bIns="0" rtlCol="0" anchor="ctr"/>
+          <a:lstStyle/>
+          <a:p>
+            <a:pPr marL="342900" indent="-342900">
+              <a:spcAft>
+                <a:spcPts val="300"/>
+              </a:spcAft>
+              <a:buSzPct val="100000"/>
+              <a:buChar char="•"/>
+            </a:pPr>
+            <a:r>
+              <a:rPr lang="en-US" sz="1100" dirty="0">
+                <a:solidFill>
+                  <a:srgbClr val="6B5848"/>
+                </a:solidFill>
+                <a:latin typeface="PingFang TC" pitchFamily="34" charset="0"/>
+                <a:ea typeface="PingFang TC" pitchFamily="34" charset="-122"/>
+                <a:cs typeface="PingFang TC" pitchFamily="34" charset="-120"/>
+              </a:rPr>
+              <a:t>異常預警通知家人</a:t>
+            </a:r>
+            <a:endParaRPr lang="en-US" sz="1100" dirty="0"/>
+          </a:p>
+          <a:p>
+            <a:pPr marL="342900" indent="-342900">
+              <a:spcAft>
+                <a:spcPts val="300"/>
+              </a:spcAft>
+              <a:buSzPct val="100000"/>
+              <a:buChar char="•"/>
+            </a:pPr>
+            <a:r>
+              <a:rPr lang="en-US" sz="1100" dirty="0">
+                <a:solidFill>
+                  <a:srgbClr val="6B5848"/>
+                </a:solidFill>
+                <a:latin typeface="PingFang TC" pitchFamily="34" charset="0"/>
+                <a:ea typeface="PingFang TC" pitchFamily="34" charset="-122"/>
+                <a:cs typeface="PingFang TC" pitchFamily="34" charset="-120"/>
+              </a:rPr>
+              <a:t>每日關懷推播</a:t>
+            </a:r>
+            <a:endParaRPr lang="en-US" sz="1100" dirty="0"/>
+          </a:p>
+          <a:p>
+            <a:pPr marL="342900" indent="-342900">
+              <a:spcAft>
+                <a:spcPts val="300"/>
+              </a:spcAft>
+              <a:buSzPct val="100000"/>
+              <a:buChar char="•"/>
+            </a:pPr>
+            <a:r>
+              <a:rPr lang="en-US" sz="1100" dirty="0">
+                <a:solidFill>
+                  <a:srgbClr val="6B5848"/>
+                </a:solidFill>
+                <a:latin typeface="PingFang TC" pitchFamily="34" charset="0"/>
+                <a:ea typeface="PingFang TC" pitchFamily="34" charset="-122"/>
+                <a:cs typeface="PingFang TC" pitchFamily="34" charset="-120"/>
+              </a:rPr>
+              <a:t>LINE 整合</a:t>
+            </a:r>
+            <a:endParaRPr lang="en-US" sz="1100" dirty="0"/>
+          </a:p>
+          <a:p>
+            <a:pPr marL="342900" indent="-342900">
+              <a:spcAft>
+                <a:spcPts val="300"/>
+              </a:spcAft>
+              <a:buSzPct val="100000"/>
+              <a:buChar char="•"/>
+            </a:pPr>
+            <a:r>
+              <a:rPr lang="en-US" sz="1100" dirty="0">
+                <a:solidFill>
+                  <a:srgbClr val="6B5848"/>
+                </a:solidFill>
+                <a:latin typeface="PingFang TC" pitchFamily="34" charset="0"/>
+                <a:ea typeface="PingFang TC" pitchFamily="34" charset="-122"/>
+                <a:cs typeface="PingFang TC" pitchFamily="34" charset="-120"/>
+              </a:rPr>
+              <a:t>子女端儀表板</a:t>
+            </a:r>
+            <a:endParaRPr lang="en-US" sz="1100" dirty="0"/>
+          </a:p>
+        </p:txBody>
+      </p:sp>
+      <p:sp>
+        <p:nvSpPr>
+          <p:cNvPr id="14" name="Shape 12"/>
+          <p:cNvSpPr/>
+          <p:nvPr/>
+        </p:nvSpPr>
+        <p:spPr>
+          <a:xfrm>
+            <a:off x="548640" y="3913632"/>
+            <a:ext cx="2606040" cy="384048"/>
+          </a:xfrm>
+          <a:prstGeom prst="rect">
+            <a:avLst/>
+          </a:prstGeom>
+          <a:solidFill>
+            <a:srgbClr val="7AA779">
+              <a:alpha val="15000"/>
+            </a:srgbClr>
+          </a:solidFill>
+          <a:ln w="12700">
+            <a:solidFill>
+              <a:srgbClr val="7AA779"/>
+            </a:solidFill>
+            <a:prstDash val="solid"/>
+          </a:ln>
+        </p:spPr>
+      </p:sp>
+      <p:sp>
+        <p:nvSpPr>
+          <p:cNvPr id="15" name="Text 13"/>
+          <p:cNvSpPr/>
+          <p:nvPr/>
+        </p:nvSpPr>
+        <p:spPr>
+          <a:xfrm>
+            <a:off x="685800" y="3913632"/>
+            <a:ext cx="2331720" cy="384048"/>
+          </a:xfrm>
+          <a:prstGeom prst="rect">
+            <a:avLst/>
+          </a:prstGeom>
+          <a:noFill/>
+          <a:ln/>
+        </p:spPr>
+        <p:txBody>
+          <a:bodyPr wrap="square" lIns="0" tIns="0" rIns="0" bIns="0" rtlCol="0" anchor="ctr"/>
+          <a:lstStyle/>
+          <a:p>
+            <a:pPr indent="0" marL="0">
+              <a:buNone/>
+            </a:pPr>
+            <a:r>
+              <a:rPr lang="en-US" sz="1100" b="1" dirty="0">
+                <a:solidFill>
+                  <a:srgbClr val="3D2E20"/>
+                </a:solidFill>
+                <a:latin typeface="PingFang TC" pitchFamily="34" charset="0"/>
+                <a:ea typeface="PingFang TC" pitchFamily="34" charset="-122"/>
+                <a:cs typeface="PingFang TC" pitchFamily="34" charset="-120"/>
+              </a:rPr>
+              <a:t>💰 訂閱分潤</a:t>
+            </a:r>
+            <a:endParaRPr lang="en-US" sz="1100" dirty="0"/>
+          </a:p>
+        </p:txBody>
+      </p:sp>
+      <p:sp>
+        <p:nvSpPr>
+          <p:cNvPr id="16" name="Shape 14"/>
+          <p:cNvSpPr/>
+          <p:nvPr/>
+        </p:nvSpPr>
+        <p:spPr>
+          <a:xfrm>
+            <a:off x="3383280" y="1600200"/>
+            <a:ext cx="2606040" cy="2697480"/>
+          </a:xfrm>
+          <a:prstGeom prst="roundRect">
+            <a:avLst>
+              <a:gd name="adj" fmla="val 4211"/>
             </a:avLst>
           </a:prstGeom>
           <a:solidFill>
@@ -7074,19 +7282,17 @@
       </p:sp>
       <p:sp>
         <p:nvSpPr>
-          <p:cNvPr id="13" name="Shape 11"/>
-          <p:cNvSpPr/>
-          <p:nvPr/>
-        </p:nvSpPr>
-        <p:spPr>
-          <a:xfrm>
-            <a:off x="3611880" y="2057400"/>
-            <a:ext cx="1188720" cy="365760"/>
-          </a:xfrm>
-          <a:prstGeom prst="roundRect">
-            <a:avLst>
-              <a:gd name="adj" fmla="val 50000"/>
-            </a:avLst>
+          <p:cNvPr id="17" name="Shape 15"/>
+          <p:cNvSpPr/>
+          <p:nvPr/>
+        </p:nvSpPr>
+        <p:spPr>
+          <a:xfrm>
+            <a:off x="3383280" y="1600200"/>
+            <a:ext cx="2606040" cy="109728"/>
+          </a:xfrm>
+          <a:prstGeom prst="rect">
+            <a:avLst/>
           </a:prstGeom>
           <a:solidFill>
             <a:srgbClr val="D9A441"/>
@@ -7101,138 +7307,348 @@
       </p:sp>
       <p:sp>
         <p:nvSpPr>
-          <p:cNvPr id="14" name="Text 12"/>
-          <p:cNvSpPr/>
-          <p:nvPr/>
-        </p:nvSpPr>
-        <p:spPr>
-          <a:xfrm>
-            <a:off x="3611880" y="2057400"/>
-            <a:ext cx="1188720" cy="365760"/>
-          </a:xfrm>
-          <a:prstGeom prst="rect">
-            <a:avLst/>
-          </a:prstGeom>
-          <a:noFill/>
-          <a:ln/>
-        </p:spPr>
-        <p:txBody>
-          <a:bodyPr wrap="square" lIns="0" tIns="0" rIns="0" bIns="0" rtlCol="0" anchor="ctr"/>
-          <a:lstStyle/>
-          <a:p>
-            <a:pPr algn="ctr" indent="0" marL="0">
-              <a:buNone/>
-            </a:pPr>
-            <a:r>
-              <a:rPr lang="en-US" sz="1100" b="1" dirty="0">
-                <a:solidFill>
-                  <a:srgbClr val="FFFFFF"/>
-                </a:solidFill>
-                <a:latin typeface="PingFang TC" pitchFamily="34" charset="0"/>
-                <a:ea typeface="PingFang TC" pitchFamily="34" charset="-122"/>
-                <a:cs typeface="PingFang TC" pitchFamily="34" charset="-120"/>
-              </a:rPr>
-              <a:t>開發中</a:t>
-            </a:r>
-            <a:endParaRPr lang="en-US" sz="1100" dirty="0"/>
-          </a:p>
-        </p:txBody>
-      </p:sp>
-      <p:sp>
-        <p:nvSpPr>
-          <p:cNvPr id="15" name="Text 13"/>
-          <p:cNvSpPr/>
-          <p:nvPr/>
-        </p:nvSpPr>
-        <p:spPr>
-          <a:xfrm>
-            <a:off x="3611880" y="2606040"/>
-            <a:ext cx="2148840" cy="457200"/>
-          </a:xfrm>
-          <a:prstGeom prst="rect">
-            <a:avLst/>
-          </a:prstGeom>
-          <a:noFill/>
-          <a:ln/>
-        </p:spPr>
-        <p:txBody>
-          <a:bodyPr wrap="square" lIns="0" tIns="0" rIns="0" bIns="0" rtlCol="0" anchor="ctr"/>
-          <a:lstStyle/>
-          <a:p>
-            <a:pPr indent="0" marL="0">
-              <a:buNone/>
-            </a:pPr>
-            <a:r>
-              <a:rPr lang="en-US" sz="2100" b="1" dirty="0">
-                <a:solidFill>
-                  <a:srgbClr val="3D2E20"/>
-                </a:solidFill>
-                <a:latin typeface="PingFang TC" pitchFamily="34" charset="0"/>
-                <a:ea typeface="PingFang TC" pitchFamily="34" charset="-122"/>
-                <a:cs typeface="PingFang TC" pitchFamily="34" charset="-120"/>
-              </a:rPr>
-              <a:t>語音週報</a:t>
-            </a:r>
-            <a:endParaRPr lang="en-US" sz="2100" dirty="0"/>
-          </a:p>
-        </p:txBody>
-      </p:sp>
-      <p:sp>
-        <p:nvSpPr>
-          <p:cNvPr id="16" name="Text 14"/>
-          <p:cNvSpPr/>
-          <p:nvPr/>
-        </p:nvSpPr>
-        <p:spPr>
-          <a:xfrm>
-            <a:off x="3611880" y="3108960"/>
-            <a:ext cx="2194560" cy="914400"/>
-          </a:xfrm>
-          <a:prstGeom prst="rect">
-            <a:avLst/>
-          </a:prstGeom>
-          <a:noFill/>
-          <a:ln/>
-        </p:spPr>
-        <p:txBody>
-          <a:bodyPr wrap="square" lIns="0" tIns="0" rIns="0" bIns="0" rtlCol="0" anchor="ctr"/>
-          <a:lstStyle/>
-          <a:p>
-            <a:pPr indent="0" marL="0">
-              <a:lnSpc>
-                <a:spcPts val="1800"/>
-              </a:lnSpc>
-              <a:buNone/>
-            </a:pPr>
-            <a:r>
-              <a:rPr lang="en-US" sz="1250" dirty="0">
-                <a:solidFill>
-                  <a:srgbClr val="6B5848"/>
-                </a:solidFill>
-                <a:latin typeface="PingFang TC" pitchFamily="34" charset="0"/>
-                <a:ea typeface="PingFang TC" pitchFamily="34" charset="-122"/>
-                <a:cs typeface="PingFang TC" pitchFamily="34" charset="-120"/>
-              </a:rPr>
-              <a:t>每週用溫暖語音，向子女回報爸媽近況</a:t>
-            </a:r>
-            <a:endParaRPr lang="en-US" sz="1250" dirty="0"/>
-          </a:p>
-        </p:txBody>
-      </p:sp>
-      <p:sp>
-        <p:nvSpPr>
-          <p:cNvPr id="17" name="Shape 15"/>
-          <p:cNvSpPr/>
-          <p:nvPr/>
-        </p:nvSpPr>
-        <p:spPr>
-          <a:xfrm>
-            <a:off x="6217920" y="1828800"/>
-            <a:ext cx="2606040" cy="2286000"/>
+          <p:cNvPr id="18" name="Shape 16"/>
+          <p:cNvSpPr/>
+          <p:nvPr/>
+        </p:nvSpPr>
+        <p:spPr>
+          <a:xfrm>
+            <a:off x="3566160" y="1828800"/>
+            <a:ext cx="1417320" cy="310896"/>
           </a:xfrm>
           <a:prstGeom prst="roundRect">
             <a:avLst>
-              <a:gd name="adj" fmla="val 6000"/>
+              <a:gd name="adj" fmla="val 50000"/>
+            </a:avLst>
+          </a:prstGeom>
+          <a:solidFill>
+            <a:srgbClr val="D9A441"/>
+          </a:solidFill>
+          <a:ln w="12700">
+            <a:solidFill>
+              <a:srgbClr val="D9A441"/>
+            </a:solidFill>
+            <a:prstDash val="solid"/>
+          </a:ln>
+        </p:spPr>
+      </p:sp>
+      <p:sp>
+        <p:nvSpPr>
+          <p:cNvPr id="19" name="Text 17"/>
+          <p:cNvSpPr/>
+          <p:nvPr/>
+        </p:nvSpPr>
+        <p:spPr>
+          <a:xfrm>
+            <a:off x="3566160" y="1828800"/>
+            <a:ext cx="1417320" cy="310896"/>
+          </a:xfrm>
+          <a:prstGeom prst="rect">
+            <a:avLst/>
+          </a:prstGeom>
+          <a:noFill/>
+          <a:ln/>
+        </p:spPr>
+        <p:txBody>
+          <a:bodyPr wrap="square" lIns="0" tIns="0" rIns="0" bIns="0" rtlCol="0" anchor="ctr"/>
+          <a:lstStyle/>
+          <a:p>
+            <a:pPr algn="ctr" indent="0" marL="0">
+              <a:buNone/>
+            </a:pPr>
+            <a:r>
+              <a:rPr lang="en-US" sz="1000" b="1" dirty="0">
+                <a:solidFill>
+                  <a:srgbClr val="FFFFFF"/>
+                </a:solidFill>
+                <a:latin typeface="PingFang TC" pitchFamily="34" charset="0"/>
+                <a:ea typeface="PingFang TC" pitchFamily="34" charset="-122"/>
+                <a:cs typeface="PingFang TC" pitchFamily="34" charset="-120"/>
+              </a:rPr>
+              <a:t>🔨 開發中</a:t>
+            </a:r>
+            <a:endParaRPr lang="en-US" sz="1000" dirty="0"/>
+          </a:p>
+        </p:txBody>
+      </p:sp>
+      <p:sp>
+        <p:nvSpPr>
+          <p:cNvPr id="20" name="Text 18"/>
+          <p:cNvSpPr/>
+          <p:nvPr/>
+        </p:nvSpPr>
+        <p:spPr>
+          <a:xfrm>
+            <a:off x="3566160" y="2212848"/>
+            <a:ext cx="2240280" cy="320040"/>
+          </a:xfrm>
+          <a:prstGeom prst="rect">
+            <a:avLst/>
+          </a:prstGeom>
+          <a:noFill/>
+          <a:ln/>
+        </p:spPr>
+        <p:txBody>
+          <a:bodyPr wrap="square" lIns="0" tIns="0" rIns="0" bIns="0" rtlCol="0" anchor="ctr"/>
+          <a:lstStyle/>
+          <a:p>
+            <a:pPr indent="0" marL="0">
+              <a:buNone/>
+            </a:pPr>
+            <a:r>
+              <a:rPr lang="en-US" sz="1600" b="1" dirty="0">
+                <a:solidFill>
+                  <a:srgbClr val="3D2E20"/>
+                </a:solidFill>
+                <a:latin typeface="PingFang TC" pitchFamily="34" charset="0"/>
+                <a:ea typeface="PingFang TC" pitchFamily="34" charset="-122"/>
+                <a:cs typeface="PingFang TC" pitchFamily="34" charset="-120"/>
+              </a:rPr>
+              <a:t>H2 · 健康平台</a:t>
+            </a:r>
+            <a:endParaRPr lang="en-US" sz="1600" dirty="0"/>
+          </a:p>
+        </p:txBody>
+      </p:sp>
+      <p:sp>
+        <p:nvSpPr>
+          <p:cNvPr id="21" name="Text 19"/>
+          <p:cNvSpPr/>
+          <p:nvPr/>
+        </p:nvSpPr>
+        <p:spPr>
+          <a:xfrm>
+            <a:off x="3566160" y="2523744"/>
+            <a:ext cx="2240280" cy="274320"/>
+          </a:xfrm>
+          <a:prstGeom prst="rect">
+            <a:avLst/>
+          </a:prstGeom>
+          <a:noFill/>
+          <a:ln/>
+        </p:spPr>
+        <p:txBody>
+          <a:bodyPr wrap="square" lIns="0" tIns="0" rIns="0" bIns="0" rtlCol="0" anchor="ctr"/>
+          <a:lstStyle/>
+          <a:p>
+            <a:pPr indent="0" marL="0">
+              <a:buNone/>
+            </a:pPr>
+            <a:r>
+              <a:rPr lang="en-US" sz="1000" dirty="0">
+                <a:solidFill>
+                  <a:srgbClr val="A89580"/>
+                </a:solidFill>
+                <a:latin typeface="PingFang TC" pitchFamily="34" charset="0"/>
+                <a:ea typeface="PingFang TC" pitchFamily="34" charset="-122"/>
+                <a:cs typeface="PingFang TC" pitchFamily="34" charset="-120"/>
+              </a:rPr>
+              <a:t>6–18 個月　</a:t>
+            </a:r>
+            <a:pPr indent="0" marL="0">
+              <a:buNone/>
+            </a:pPr>
+            <a:r>
+              <a:rPr lang="en-US" sz="1100" b="1" dirty="0">
+                <a:solidFill>
+                  <a:srgbClr val="D9A441"/>
+                </a:solidFill>
+                <a:latin typeface="PingFang TC" pitchFamily="34" charset="0"/>
+                <a:ea typeface="PingFang TC" pitchFamily="34" charset="-122"/>
+                <a:cs typeface="PingFang TC" pitchFamily="34" charset="-120"/>
+              </a:rPr>
+              <a:t>讓數據有價值</a:t>
+            </a:r>
+            <a:endParaRPr lang="en-US" sz="1000" dirty="0"/>
+          </a:p>
+        </p:txBody>
+      </p:sp>
+      <p:sp>
+        <p:nvSpPr>
+          <p:cNvPr id="22" name="Text 20"/>
+          <p:cNvSpPr/>
+          <p:nvPr/>
+        </p:nvSpPr>
+        <p:spPr>
+          <a:xfrm>
+            <a:off x="3611880" y="2852928"/>
+            <a:ext cx="2194560" cy="960120"/>
+          </a:xfrm>
+          <a:prstGeom prst="rect">
+            <a:avLst/>
+          </a:prstGeom>
+          <a:noFill/>
+          <a:ln/>
+        </p:spPr>
+        <p:txBody>
+          <a:bodyPr wrap="square" lIns="0" tIns="0" rIns="0" bIns="0" rtlCol="0" anchor="ctr"/>
+          <a:lstStyle/>
+          <a:p>
+            <a:pPr marL="342900" indent="-342900">
+              <a:spcAft>
+                <a:spcPts val="300"/>
+              </a:spcAft>
+              <a:buSzPct val="100000"/>
+              <a:buChar char="•"/>
+            </a:pPr>
+            <a:r>
+              <a:rPr lang="en-US" sz="1100" dirty="0">
+                <a:solidFill>
+                  <a:srgbClr val="6B5848"/>
+                </a:solidFill>
+                <a:latin typeface="PingFang TC" pitchFamily="34" charset="0"/>
+                <a:ea typeface="PingFang TC" pitchFamily="34" charset="-122"/>
+                <a:cs typeface="PingFang TC" pitchFamily="34" charset="-120"/>
+              </a:rPr>
+              <a:t>慢病管理 + 回診</a:t>
+            </a:r>
+            <a:endParaRPr lang="en-US" sz="1100" dirty="0"/>
+          </a:p>
+          <a:p>
+            <a:pPr marL="342900" indent="-342900">
+              <a:spcAft>
+                <a:spcPts val="300"/>
+              </a:spcAft>
+              <a:buSzPct val="100000"/>
+              <a:buChar char="•"/>
+            </a:pPr>
+            <a:r>
+              <a:rPr lang="en-US" sz="1100" dirty="0">
+                <a:solidFill>
+                  <a:srgbClr val="6B5848"/>
+                </a:solidFill>
+                <a:latin typeface="PingFang TC" pitchFamily="34" charset="0"/>
+                <a:ea typeface="PingFang TC" pitchFamily="34" charset="-122"/>
+                <a:cs typeface="PingFang TC" pitchFamily="34" charset="-120"/>
+              </a:rPr>
+              <a:t>藍牙血壓計整合</a:t>
+            </a:r>
+            <a:endParaRPr lang="en-US" sz="1100" dirty="0"/>
+          </a:p>
+          <a:p>
+            <a:pPr marL="342900" indent="-342900">
+              <a:spcAft>
+                <a:spcPts val="300"/>
+              </a:spcAft>
+              <a:buSzPct val="100000"/>
+              <a:buChar char="•"/>
+            </a:pPr>
+            <a:r>
+              <a:rPr lang="en-US" sz="1100" dirty="0">
+                <a:solidFill>
+                  <a:srgbClr val="6B5848"/>
+                </a:solidFill>
+                <a:latin typeface="PingFang TC" pitchFamily="34" charset="0"/>
+                <a:ea typeface="PingFang TC" pitchFamily="34" charset="-122"/>
+                <a:cs typeface="PingFang TC" pitchFamily="34" charset="-120"/>
+              </a:rPr>
+              <a:t>遠距諮詢對接</a:t>
+            </a:r>
+            <a:endParaRPr lang="en-US" sz="1100" dirty="0"/>
+          </a:p>
+          <a:p>
+            <a:pPr marL="342900" indent="-342900">
+              <a:spcAft>
+                <a:spcPts val="300"/>
+              </a:spcAft>
+              <a:buSzPct val="100000"/>
+              <a:buChar char="•"/>
+            </a:pPr>
+            <a:r>
+              <a:rPr lang="en-US" sz="1100" dirty="0">
+                <a:solidFill>
+                  <a:srgbClr val="6B5848"/>
+                </a:solidFill>
+                <a:latin typeface="PingFang TC" pitchFamily="34" charset="0"/>
+                <a:ea typeface="PingFang TC" pitchFamily="34" charset="-122"/>
+                <a:cs typeface="PingFang TC" pitchFamily="34" charset="-120"/>
+              </a:rPr>
+              <a:t>健康數據 API</a:t>
+            </a:r>
+            <a:endParaRPr lang="en-US" sz="1100" dirty="0"/>
+          </a:p>
+        </p:txBody>
+      </p:sp>
+      <p:sp>
+        <p:nvSpPr>
+          <p:cNvPr id="23" name="Shape 21"/>
+          <p:cNvSpPr/>
+          <p:nvPr/>
+        </p:nvSpPr>
+        <p:spPr>
+          <a:xfrm>
+            <a:off x="3383280" y="3913632"/>
+            <a:ext cx="2606040" cy="384048"/>
+          </a:xfrm>
+          <a:prstGeom prst="rect">
+            <a:avLst/>
+          </a:prstGeom>
+          <a:solidFill>
+            <a:srgbClr val="D9A441">
+              <a:alpha val="15000"/>
+            </a:srgbClr>
+          </a:solidFill>
+          <a:ln w="12700">
+            <a:solidFill>
+              <a:srgbClr val="D9A441"/>
+            </a:solidFill>
+            <a:prstDash val="solid"/>
+          </a:ln>
+        </p:spPr>
+      </p:sp>
+      <p:sp>
+        <p:nvSpPr>
+          <p:cNvPr id="24" name="Text 22"/>
+          <p:cNvSpPr/>
+          <p:nvPr/>
+        </p:nvSpPr>
+        <p:spPr>
+          <a:xfrm>
+            <a:off x="3520440" y="3913632"/>
+            <a:ext cx="2331720" cy="384048"/>
+          </a:xfrm>
+          <a:prstGeom prst="rect">
+            <a:avLst/>
+          </a:prstGeom>
+          <a:noFill/>
+          <a:ln/>
+        </p:spPr>
+        <p:txBody>
+          <a:bodyPr wrap="square" lIns="0" tIns="0" rIns="0" bIns="0" rtlCol="0" anchor="ctr"/>
+          <a:lstStyle/>
+          <a:p>
+            <a:pPr indent="0" marL="0">
+              <a:buNone/>
+            </a:pPr>
+            <a:r>
+              <a:rPr lang="en-US" sz="1100" b="1" dirty="0">
+                <a:solidFill>
+                  <a:srgbClr val="3D2E20"/>
+                </a:solidFill>
+                <a:latin typeface="PingFang TC" pitchFamily="34" charset="0"/>
+                <a:ea typeface="PingFang TC" pitchFamily="34" charset="-122"/>
+                <a:cs typeface="PingFang TC" pitchFamily="34" charset="-120"/>
+              </a:rPr>
+              <a:t>💰 軟硬整合 + 數據授權</a:t>
+            </a:r>
+            <a:endParaRPr lang="en-US" sz="1100" dirty="0"/>
+          </a:p>
+        </p:txBody>
+      </p:sp>
+      <p:sp>
+        <p:nvSpPr>
+          <p:cNvPr id="25" name="Shape 23"/>
+          <p:cNvSpPr/>
+          <p:nvPr/>
+        </p:nvSpPr>
+        <p:spPr>
+          <a:xfrm>
+            <a:off x="6217920" y="1600200"/>
+            <a:ext cx="2606040" cy="2697480"/>
+          </a:xfrm>
+          <a:prstGeom prst="roundRect">
+            <a:avLst>
+              <a:gd name="adj" fmla="val 4211"/>
             </a:avLst>
           </a:prstGeom>
           <a:solidFill>
@@ -7255,14 +7671,39 @@
       </p:sp>
       <p:sp>
         <p:nvSpPr>
-          <p:cNvPr id="18" name="Shape 16"/>
-          <p:cNvSpPr/>
-          <p:nvPr/>
-        </p:nvSpPr>
-        <p:spPr>
-          <a:xfrm>
-            <a:off x="6446520" y="2057400"/>
-            <a:ext cx="1188720" cy="365760"/>
+          <p:cNvPr id="26" name="Shape 24"/>
+          <p:cNvSpPr/>
+          <p:nvPr/>
+        </p:nvSpPr>
+        <p:spPr>
+          <a:xfrm>
+            <a:off x="6217920" y="1600200"/>
+            <a:ext cx="2606040" cy="109728"/>
+          </a:xfrm>
+          <a:prstGeom prst="rect">
+            <a:avLst/>
+          </a:prstGeom>
+          <a:solidFill>
+            <a:srgbClr val="E8845A"/>
+          </a:solidFill>
+          <a:ln w="12700">
+            <a:solidFill>
+              <a:srgbClr val="E8845A"/>
+            </a:solidFill>
+            <a:prstDash val="solid"/>
+          </a:ln>
+        </p:spPr>
+      </p:sp>
+      <p:sp>
+        <p:nvSpPr>
+          <p:cNvPr id="27" name="Shape 25"/>
+          <p:cNvSpPr/>
+          <p:nvPr/>
+        </p:nvSpPr>
+        <p:spPr>
+          <a:xfrm>
+            <a:off x="6400800" y="1828800"/>
+            <a:ext cx="1417320" cy="310896"/>
           </a:xfrm>
           <a:prstGeom prst="roundRect">
             <a:avLst>
@@ -7282,14 +7723,14 @@
       </p:sp>
       <p:sp>
         <p:nvSpPr>
-          <p:cNvPr id="19" name="Text 17"/>
-          <p:cNvSpPr/>
-          <p:nvPr/>
-        </p:nvSpPr>
-        <p:spPr>
-          <a:xfrm>
-            <a:off x="6446520" y="2057400"/>
-            <a:ext cx="1188720" cy="365760"/>
+          <p:cNvPr id="28" name="Text 26"/>
+          <p:cNvSpPr/>
+          <p:nvPr/>
+        </p:nvSpPr>
+        <p:spPr>
+          <a:xfrm>
+            <a:off x="6400800" y="1828800"/>
+            <a:ext cx="1417320" cy="310896"/>
           </a:xfrm>
           <a:prstGeom prst="rect">
             <a:avLst/>
@@ -7305,88 +7746,163 @@
               <a:buNone/>
             </a:pPr>
             <a:r>
+              <a:rPr lang="en-US" sz="1000" b="1" dirty="0">
+                <a:solidFill>
+                  <a:srgbClr val="FFFFFF"/>
+                </a:solidFill>
+                <a:latin typeface="PingFang TC" pitchFamily="34" charset="0"/>
+                <a:ea typeface="PingFang TC" pitchFamily="34" charset="-122"/>
+                <a:cs typeface="PingFang TC" pitchFamily="34" charset="-120"/>
+              </a:rPr>
+              <a:t>🌱 藍圖</a:t>
+            </a:r>
+            <a:endParaRPr lang="en-US" sz="1000" dirty="0"/>
+          </a:p>
+        </p:txBody>
+      </p:sp>
+      <p:sp>
+        <p:nvSpPr>
+          <p:cNvPr id="29" name="Text 27"/>
+          <p:cNvSpPr/>
+          <p:nvPr/>
+        </p:nvSpPr>
+        <p:spPr>
+          <a:xfrm>
+            <a:off x="6400800" y="2212848"/>
+            <a:ext cx="2240280" cy="320040"/>
+          </a:xfrm>
+          <a:prstGeom prst="rect">
+            <a:avLst/>
+          </a:prstGeom>
+          <a:noFill/>
+          <a:ln/>
+        </p:spPr>
+        <p:txBody>
+          <a:bodyPr wrap="square" lIns="0" tIns="0" rIns="0" bIns="0" rtlCol="0" anchor="ctr"/>
+          <a:lstStyle/>
+          <a:p>
+            <a:pPr indent="0" marL="0">
+              <a:buNone/>
+            </a:pPr>
+            <a:r>
+              <a:rPr lang="en-US" sz="1600" b="1" dirty="0">
+                <a:solidFill>
+                  <a:srgbClr val="3D2E20"/>
+                </a:solidFill>
+                <a:latin typeface="PingFang TC" pitchFamily="34" charset="0"/>
+                <a:ea typeface="PingFang TC" pitchFamily="34" charset="-122"/>
+                <a:cs typeface="PingFang TC" pitchFamily="34" charset="-120"/>
+              </a:rPr>
+              <a:t>H3 · 銀髮生態系</a:t>
+            </a:r>
+            <a:endParaRPr lang="en-US" sz="1600" dirty="0"/>
+          </a:p>
+        </p:txBody>
+      </p:sp>
+      <p:sp>
+        <p:nvSpPr>
+          <p:cNvPr id="30" name="Text 28"/>
+          <p:cNvSpPr/>
+          <p:nvPr/>
+        </p:nvSpPr>
+        <p:spPr>
+          <a:xfrm>
+            <a:off x="6400800" y="2523744"/>
+            <a:ext cx="2240280" cy="274320"/>
+          </a:xfrm>
+          <a:prstGeom prst="rect">
+            <a:avLst/>
+          </a:prstGeom>
+          <a:noFill/>
+          <a:ln/>
+        </p:spPr>
+        <p:txBody>
+          <a:bodyPr wrap="square" lIns="0" tIns="0" rIns="0" bIns="0" rtlCol="0" anchor="ctr"/>
+          <a:lstStyle/>
+          <a:p>
+            <a:pPr indent="0" marL="0">
+              <a:buNone/>
+            </a:pPr>
+            <a:r>
+              <a:rPr lang="en-US" sz="1000" dirty="0">
+                <a:solidFill>
+                  <a:srgbClr val="A89580"/>
+                </a:solidFill>
+                <a:latin typeface="PingFang TC" pitchFamily="34" charset="0"/>
+                <a:ea typeface="PingFang TC" pitchFamily="34" charset="-122"/>
+                <a:cs typeface="PingFang TC" pitchFamily="34" charset="-120"/>
+              </a:rPr>
+              <a:t>18 個月+　</a:t>
+            </a:r>
+            <a:pPr indent="0" marL="0">
+              <a:buNone/>
+            </a:pPr>
+            <a:r>
               <a:rPr lang="en-US" sz="1100" b="1" dirty="0">
                 <a:solidFill>
-                  <a:srgbClr val="FFFFFF"/>
-                </a:solidFill>
-                <a:latin typeface="PingFang TC" pitchFamily="34" charset="0"/>
-                <a:ea typeface="PingFang TC" pitchFamily="34" charset="-122"/>
-                <a:cs typeface="PingFang TC" pitchFamily="34" charset="-120"/>
-              </a:rPr>
-              <a:t>藍圖</a:t>
+                  <a:srgbClr val="E8845A"/>
+                </a:solidFill>
+                <a:latin typeface="PingFang TC" pitchFamily="34" charset="0"/>
+                <a:ea typeface="PingFang TC" pitchFamily="34" charset="-122"/>
+                <a:cs typeface="PingFang TC" pitchFamily="34" charset="-120"/>
+              </a:rPr>
+              <a:t>成為銀髮入口</a:t>
+            </a:r>
+            <a:endParaRPr lang="en-US" sz="1000" dirty="0"/>
+          </a:p>
+        </p:txBody>
+      </p:sp>
+      <p:sp>
+        <p:nvSpPr>
+          <p:cNvPr id="31" name="Text 29"/>
+          <p:cNvSpPr/>
+          <p:nvPr/>
+        </p:nvSpPr>
+        <p:spPr>
+          <a:xfrm>
+            <a:off x="6446520" y="2852928"/>
+            <a:ext cx="2194560" cy="960120"/>
+          </a:xfrm>
+          <a:prstGeom prst="rect">
+            <a:avLst/>
+          </a:prstGeom>
+          <a:noFill/>
+          <a:ln/>
+        </p:spPr>
+        <p:txBody>
+          <a:bodyPr wrap="square" lIns="0" tIns="0" rIns="0" bIns="0" rtlCol="0" anchor="ctr"/>
+          <a:lstStyle/>
+          <a:p>
+            <a:pPr marL="342900" indent="-342900">
+              <a:spcAft>
+                <a:spcPts val="300"/>
+              </a:spcAft>
+              <a:buSzPct val="100000"/>
+              <a:buChar char="•"/>
+            </a:pPr>
+            <a:r>
+              <a:rPr lang="en-US" sz="1100" dirty="0">
+                <a:solidFill>
+                  <a:srgbClr val="6B5848"/>
+                </a:solidFill>
+                <a:latin typeface="PingFang TC" pitchFamily="34" charset="0"/>
+                <a:ea typeface="PingFang TC" pitchFamily="34" charset="-122"/>
+                <a:cs typeface="PingFang TC" pitchFamily="34" charset="-120"/>
+              </a:rPr>
+              <a:t>保險風險方案</a:t>
             </a:r>
             <a:endParaRPr lang="en-US" sz="1100" dirty="0"/>
           </a:p>
-        </p:txBody>
-      </p:sp>
-      <p:sp>
-        <p:nvSpPr>
-          <p:cNvPr id="20" name="Text 18"/>
-          <p:cNvSpPr/>
-          <p:nvPr/>
-        </p:nvSpPr>
-        <p:spPr>
-          <a:xfrm>
-            <a:off x="6446520" y="2606040"/>
-            <a:ext cx="2148840" cy="457200"/>
-          </a:xfrm>
-          <a:prstGeom prst="rect">
-            <a:avLst/>
-          </a:prstGeom>
-          <a:noFill/>
-          <a:ln/>
-        </p:spPr>
-        <p:txBody>
-          <a:bodyPr wrap="square" lIns="0" tIns="0" rIns="0" bIns="0" rtlCol="0" anchor="ctr"/>
-          <a:lstStyle/>
-          <a:p>
-            <a:pPr indent="0" marL="0">
-              <a:buNone/>
-            </a:pPr>
-            <a:r>
-              <a:rPr lang="en-US" sz="2100" b="1" dirty="0">
-                <a:solidFill>
-                  <a:srgbClr val="3D2E20"/>
-                </a:solidFill>
-                <a:latin typeface="PingFang TC" pitchFamily="34" charset="0"/>
-                <a:ea typeface="PingFang TC" pitchFamily="34" charset="-122"/>
-                <a:cs typeface="PingFang TC" pitchFamily="34" charset="-120"/>
-              </a:rPr>
-              <a:t>主動關懷來電</a:t>
-            </a:r>
-            <a:endParaRPr lang="en-US" sz="2100" dirty="0"/>
-          </a:p>
-        </p:txBody>
-      </p:sp>
-      <p:sp>
-        <p:nvSpPr>
-          <p:cNvPr id="21" name="Text 19"/>
-          <p:cNvSpPr/>
-          <p:nvPr/>
-        </p:nvSpPr>
-        <p:spPr>
-          <a:xfrm>
-            <a:off x="6446520" y="3108960"/>
-            <a:ext cx="2194560" cy="914400"/>
-          </a:xfrm>
-          <a:prstGeom prst="rect">
-            <a:avLst/>
-          </a:prstGeom>
-          <a:noFill/>
-          <a:ln/>
-        </p:spPr>
-        <p:txBody>
-          <a:bodyPr wrap="square" lIns="0" tIns="0" rIns="0" bIns="0" rtlCol="0" anchor="ctr"/>
-          <a:lstStyle/>
-          <a:p>
-            <a:pPr indent="0" marL="0">
-              <a:lnSpc>
-                <a:spcPts val="1800"/>
-              </a:lnSpc>
-              <a:buNone/>
-            </a:pPr>
-            <a:r>
-              <a:rPr lang="en-US" sz="1250" dirty="0">
+          <a:p>
+            <a:pPr marL="342900" indent="-342900">
+              <a:spcAft>
+                <a:spcPts val="300"/>
+              </a:spcAft>
+              <a:buSzPct val="100000"/>
+              <a:buChar char="•"/>
+            </a:pPr>
+            <a:r>
+              <a:rPr lang="en-US" sz="1100" dirty="0">
                 <a:solidFill>
                   <a:srgbClr val="6B5848"/>
                 </a:solidFill>
@@ -7394,30 +7910,72 @@
                 <a:ea typeface="PingFang TC" pitchFamily="34" charset="-122"/>
                 <a:cs typeface="PingFang TC" pitchFamily="34" charset="-120"/>
               </a:rPr>
-              <a:t>暖暖每天主動「打給」長輩問候、提醒</a:t>
-            </a:r>
-            <a:endParaRPr lang="en-US" sz="1250" dirty="0"/>
-          </a:p>
-        </p:txBody>
-      </p:sp>
-      <p:sp>
-        <p:nvSpPr>
-          <p:cNvPr id="22" name="Shape 20"/>
-          <p:cNvSpPr/>
-          <p:nvPr/>
-        </p:nvSpPr>
-        <p:spPr>
-          <a:xfrm>
-            <a:off x="548640" y="4434840"/>
-            <a:ext cx="8046720" cy="502920"/>
-          </a:xfrm>
-          <a:prstGeom prst="roundRect">
-            <a:avLst>
-              <a:gd name="adj" fmla="val 21818"/>
-            </a:avLst>
-          </a:prstGeom>
-          <a:solidFill>
-            <a:srgbClr val="E8845A"/>
+              <a:t>長照機構後台</a:t>
+            </a:r>
+            <a:endParaRPr lang="en-US" sz="1100" dirty="0"/>
+          </a:p>
+          <a:p>
+            <a:pPr marL="342900" indent="-342900">
+              <a:spcAft>
+                <a:spcPts val="300"/>
+              </a:spcAft>
+              <a:buSzPct val="100000"/>
+              <a:buChar char="•"/>
+            </a:pPr>
+            <a:r>
+              <a:rPr lang="en-US" sz="1100" dirty="0">
+                <a:solidFill>
+                  <a:srgbClr val="6B5848"/>
+                </a:solidFill>
+                <a:latin typeface="PingFang TC" pitchFamily="34" charset="0"/>
+                <a:ea typeface="PingFang TC" pitchFamily="34" charset="-122"/>
+                <a:cs typeface="PingFang TC" pitchFamily="34" charset="-120"/>
+              </a:rPr>
+              <a:t>健康電商導購</a:t>
+            </a:r>
+            <a:endParaRPr lang="en-US" sz="1100" dirty="0"/>
+          </a:p>
+          <a:p>
+            <a:pPr marL="342900" indent="-342900">
+              <a:spcAft>
+                <a:spcPts val="300"/>
+              </a:spcAft>
+              <a:buSzPct val="100000"/>
+              <a:buChar char="•"/>
+            </a:pPr>
+            <a:r>
+              <a:rPr lang="en-US" sz="1100" dirty="0">
+                <a:solidFill>
+                  <a:srgbClr val="6B5848"/>
+                </a:solidFill>
+                <a:latin typeface="PingFang TC" pitchFamily="34" charset="0"/>
+                <a:ea typeface="PingFang TC" pitchFamily="34" charset="-122"/>
+                <a:cs typeface="PingFang TC" pitchFamily="34" charset="-120"/>
+              </a:rPr>
+              <a:t>AI 風險預測</a:t>
+            </a:r>
+            <a:endParaRPr lang="en-US" sz="1100" dirty="0"/>
+          </a:p>
+        </p:txBody>
+      </p:sp>
+      <p:sp>
+        <p:nvSpPr>
+          <p:cNvPr id="32" name="Shape 30"/>
+          <p:cNvSpPr/>
+          <p:nvPr/>
+        </p:nvSpPr>
+        <p:spPr>
+          <a:xfrm>
+            <a:off x="6217920" y="3913632"/>
+            <a:ext cx="2606040" cy="384048"/>
+          </a:xfrm>
+          <a:prstGeom prst="rect">
+            <a:avLst/>
+          </a:prstGeom>
+          <a:solidFill>
+            <a:srgbClr val="E8845A">
+              <a:alpha val="15000"/>
+            </a:srgbClr>
           </a:solidFill>
           <a:ln w="12700">
             <a:solidFill>
@@ -7429,14 +7987,80 @@
       </p:sp>
       <p:sp>
         <p:nvSpPr>
-          <p:cNvPr id="23" name="Text 21"/>
-          <p:cNvSpPr/>
-          <p:nvPr/>
-        </p:nvSpPr>
-        <p:spPr>
-          <a:xfrm>
-            <a:off x="548640" y="4434840"/>
-            <a:ext cx="8046720" cy="502920"/>
+          <p:cNvPr id="33" name="Text 31"/>
+          <p:cNvSpPr/>
+          <p:nvPr/>
+        </p:nvSpPr>
+        <p:spPr>
+          <a:xfrm>
+            <a:off x="6355080" y="3913632"/>
+            <a:ext cx="2331720" cy="384048"/>
+          </a:xfrm>
+          <a:prstGeom prst="rect">
+            <a:avLst/>
+          </a:prstGeom>
+          <a:noFill/>
+          <a:ln/>
+        </p:spPr>
+        <p:txBody>
+          <a:bodyPr wrap="square" lIns="0" tIns="0" rIns="0" bIns="0" rtlCol="0" anchor="ctr"/>
+          <a:lstStyle/>
+          <a:p>
+            <a:pPr indent="0" marL="0">
+              <a:buNone/>
+            </a:pPr>
+            <a:r>
+              <a:rPr lang="en-US" sz="1100" b="1" dirty="0">
+                <a:solidFill>
+                  <a:srgbClr val="3D2E20"/>
+                </a:solidFill>
+                <a:latin typeface="PingFang TC" pitchFamily="34" charset="0"/>
+                <a:ea typeface="PingFang TC" pitchFamily="34" charset="-122"/>
+                <a:cs typeface="PingFang TC" pitchFamily="34" charset="-120"/>
+              </a:rPr>
+              <a:t>💰 B2B 大單 + 導購分潤</a:t>
+            </a:r>
+            <a:endParaRPr lang="en-US" sz="1100" dirty="0"/>
+          </a:p>
+        </p:txBody>
+      </p:sp>
+      <p:sp>
+        <p:nvSpPr>
+          <p:cNvPr id="34" name="Shape 32"/>
+          <p:cNvSpPr/>
+          <p:nvPr/>
+        </p:nvSpPr>
+        <p:spPr>
+          <a:xfrm>
+            <a:off x="548640" y="4480560"/>
+            <a:ext cx="8046720" cy="457200"/>
+          </a:xfrm>
+          <a:prstGeom prst="roundRect">
+            <a:avLst>
+              <a:gd name="adj" fmla="val 20000"/>
+            </a:avLst>
+          </a:prstGeom>
+          <a:solidFill>
+            <a:srgbClr val="E8845A"/>
+          </a:solidFill>
+          <a:ln w="12700">
+            <a:solidFill>
+              <a:srgbClr val="E8845A"/>
+            </a:solidFill>
+            <a:prstDash val="solid"/>
+          </a:ln>
+        </p:spPr>
+      </p:sp>
+      <p:sp>
+        <p:nvSpPr>
+          <p:cNvPr id="35" name="Text 33"/>
+          <p:cNvSpPr/>
+          <p:nvPr/>
+        </p:nvSpPr>
+        <p:spPr>
+          <a:xfrm>
+            <a:off x="548640" y="4480560"/>
+            <a:ext cx="8046720" cy="457200"/>
           </a:xfrm>
           <a:prstGeom prst="rect">
             <a:avLst/>
@@ -7452,7 +8076,7 @@
               <a:buNone/>
             </a:pPr>
             <a:r>
-              <a:rPr lang="en-US" sz="1400" b="1" dirty="0">
+              <a:rPr lang="en-US" sz="1300" b="1" dirty="0">
                 <a:solidFill>
                   <a:srgbClr val="FFFFFF"/>
                 </a:solidFill>
@@ -7460,9 +8084,9 @@
                 <a:ea typeface="PingFang TC" pitchFamily="34" charset="-122"/>
                 <a:cs typeface="PingFang TC" pitchFamily="34" charset="-120"/>
               </a:rPr>
-              <a:t>早期合作的夥伴，會一起參與這個守護藍圖</a:t>
-            </a:r>
-            <a:endParaRPr lang="en-US" sz="1400" dirty="0"/>
+              <a:t>早期夥伴 = 在每個新階段都享優先權與更好條件</a:t>
+            </a:r>
+            <a:endParaRPr lang="en-US" sz="1300" dirty="0"/>
           </a:p>
         </p:txBody>
       </p:sp>

</xml_diff>